<commit_message>
Présentation PFE : ajout d'une section démonstration avec captures d'écran
docs/TousLocation-Soutenance.pptx : 28 diapositives — ajout d'une section
« Démonstration de l'application » avec 10 captures d'écran réelles
(connexion, boutiques, tableau de bord/Kanban, catalogue, locations, achats,
rapports, paramètres, place de marché/panier, mes locations).
</commit_message>
<xml_diff>
--- a/docs/TousLocation-Soutenance.pptx
+++ b/docs/TousLocation-Soutenance.pptx
@@ -22,6 +22,17 @@
     <p:sldId id="270" r:id="rId21"/>
     <p:sldId id="271" r:id="rId22"/>
     <p:sldId id="272" r:id="rId23"/>
+    <p:sldId id="273" r:id="rId24"/>
+    <p:sldId id="274" r:id="rId25"/>
+    <p:sldId id="275" r:id="rId26"/>
+    <p:sldId id="276" r:id="rId27"/>
+    <p:sldId id="277" r:id="rId28"/>
+    <p:sldId id="278" r:id="rId29"/>
+    <p:sldId id="279" r:id="rId30"/>
+    <p:sldId id="280" r:id="rId31"/>
+    <p:sldId id="281" r:id="rId32"/>
+    <p:sldId id="282" r:id="rId33"/>
+    <p:sldId id="283" r:id="rId34"/>
   </p:sldIdLst>
   <p:sldSz cx="12191695" cy="6858000" type="screen4x3"/>
   <p:notesSz cx="6858000" cy="9144000"/>
@@ -5454,7 +5465,7 @@
     <p:bg>
       <p:bgPr>
         <a:solidFill>
-          <a:srgbClr val="FFFFFF"/>
+          <a:srgbClr val="0A2540"/>
         </a:solidFill>
         <a:effectLst/>
       </p:bgPr>
@@ -5475,7 +5486,7 @@
         <p:spPr>
           <a:xfrm>
             <a:off x="0" y="0"/>
-            <a:ext cx="12191695" cy="164592"/>
+            <a:ext cx="12191695" cy="201168"/>
           </a:xfrm>
           <a:prstGeom prst="rect">
             <a:avLst/>
@@ -5518,8 +5529,8 @@
         </p:nvSpPr>
         <p:spPr>
           <a:xfrm>
-            <a:off x="640080" y="502920"/>
-            <a:ext cx="10881360" cy="365760"/>
+            <a:off x="914400" y="2743200"/>
+            <a:ext cx="10360152" cy="914400"/>
           </a:xfrm>
           <a:prstGeom prst="rect">
             <a:avLst/>
@@ -5532,14 +5543,15 @@
           </a:bodyPr>
           <a:lstStyle/>
           <a:p>
-            <a:r>
-              <a:rPr sz="1200" b="1" i="0">
-                <a:solidFill>
-                  <a:srgbClr val="0071E3"/>
-                </a:solidFill>
-                <a:latin typeface="Calibri"/>
-              </a:rPr>
-              <a:t>MISE EN ŒUVRE</a:t>
+            <a:pPr algn="ctr"/>
+            <a:r>
+              <a:rPr sz="3400" b="1" i="0">
+                <a:solidFill>
+                  <a:srgbClr val="FFFFFF"/>
+                </a:solidFill>
+                <a:latin typeface="Calibri"/>
+              </a:rPr>
+              <a:t>Démonstration de l'application</a:t>
             </a:r>
           </a:p>
         </p:txBody>
@@ -5552,8 +5564,8 @@
         </p:nvSpPr>
         <p:spPr>
           <a:xfrm>
-            <a:off x="640080" y="777240"/>
-            <a:ext cx="10881360" cy="822960"/>
+            <a:off x="914400" y="3749039"/>
+            <a:ext cx="10360152" cy="548640"/>
           </a:xfrm>
           <a:prstGeom prst="rect">
             <a:avLst/>
@@ -5566,230 +5578,15 @@
           </a:bodyPr>
           <a:lstStyle/>
           <a:p>
-            <a:r>
-              <a:rPr sz="3000" b="1" i="0">
-                <a:solidFill>
-                  <a:srgbClr val="0A2540"/>
-                </a:solidFill>
-                <a:latin typeface="Calibri"/>
-              </a:rPr>
-              <a:t>Déploiement et démonstration</a:t>
-            </a:r>
-          </a:p>
-        </p:txBody>
-      </p:sp>
-      <p:sp>
-        <p:nvSpPr>
-          <p:cNvPr id="5" name="Rectangle 4"/>
-          <p:cNvSpPr/>
-          <p:nvPr/>
-        </p:nvSpPr>
-        <p:spPr>
-          <a:xfrm>
-            <a:off x="658368" y="1481328"/>
-            <a:ext cx="1005840" cy="45720"/>
-          </a:xfrm>
-          <a:prstGeom prst="rect">
-            <a:avLst/>
-          </a:prstGeom>
-          <a:solidFill>
-            <a:srgbClr val="0071E3"/>
-          </a:solidFill>
-          <a:ln>
-            <a:noFill/>
-          </a:ln>
-          <a:effectLst/>
-        </p:spPr>
-        <p:style>
-          <a:lnRef idx="1">
-            <a:schemeClr val="accent1"/>
-          </a:lnRef>
-          <a:fillRef idx="3">
-            <a:schemeClr val="accent1"/>
-          </a:fillRef>
-          <a:effectRef idx="2">
-            <a:schemeClr val="accent1"/>
-          </a:effectRef>
-          <a:fontRef idx="minor">
-            <a:schemeClr val="lt1"/>
-          </a:fontRef>
-        </p:style>
-        <p:txBody>
-          <a:bodyPr rtlCol="0" anchor="ctr"/>
-          <a:lstStyle/>
-          <a:p>
             <a:pPr algn="ctr"/>
-          </a:p>
-        </p:txBody>
-      </p:sp>
-      <p:sp>
-        <p:nvSpPr>
-          <p:cNvPr id="6" name="TextBox 5"/>
-          <p:cNvSpPr txBox="1"/>
-          <p:nvPr/>
-        </p:nvSpPr>
-        <p:spPr>
-          <a:xfrm>
-            <a:off x="731520" y="1828800"/>
-            <a:ext cx="10698480" cy="4572000"/>
-          </a:xfrm>
-          <a:prstGeom prst="rect">
-            <a:avLst/>
-          </a:prstGeom>
-          <a:noFill/>
-        </p:spPr>
-        <p:txBody>
-          <a:bodyPr wrap="square">
-            <a:spAutoFit/>
-          </a:bodyPr>
-          <a:lstStyle/>
-          <a:p>
-            <a:pPr>
-              <a:spcBef>
-                <a:spcPts val="200"/>
-              </a:spcBef>
-              <a:spcAft>
-                <a:spcPts val="800"/>
-              </a:spcAft>
-            </a:pPr>
-            <a:r>
-              <a:rPr sz="2000" b="1" i="0">
-                <a:solidFill>
-                  <a:srgbClr val="0071E3"/>
-                </a:solidFill>
-                <a:latin typeface="Calibri"/>
-              </a:rPr>
-              <a:t>▸ </a:t>
-            </a:r>
-            <a:r>
-              <a:rPr sz="2000" b="0" i="0">
-                <a:solidFill>
-                  <a:srgbClr val="1D1D1F"/>
-                </a:solidFill>
-                <a:latin typeface="Calibri"/>
-              </a:rPr>
-              <a:t>Installation Windows « en un clic » (script automatisé : dépendances, base, données de démo).</a:t>
-            </a:r>
-          </a:p>
-          <a:p>
-            <a:pPr>
-              <a:spcBef>
-                <a:spcPts val="200"/>
-              </a:spcBef>
-              <a:spcAft>
-                <a:spcPts val="800"/>
-              </a:spcAft>
-            </a:pPr>
-            <a:r>
-              <a:rPr sz="2000" b="1" i="0">
-                <a:solidFill>
-                  <a:srgbClr val="0071E3"/>
-                </a:solidFill>
-                <a:latin typeface="Calibri"/>
-              </a:rPr>
-              <a:t>▸ </a:t>
-            </a:r>
-            <a:r>
-              <a:rPr sz="2000" b="1" i="0">
-                <a:solidFill>
-                  <a:srgbClr val="0A2540"/>
-                </a:solidFill>
-                <a:latin typeface="Calibri"/>
-              </a:rPr>
-              <a:t>Backend : http://127.0.0.1:8000</a:t>
-            </a:r>
-            <a:r>
-              <a:rPr sz="2000" b="0" i="0">
-                <a:solidFill>
-                  <a:srgbClr val="1D1D1F"/>
-                </a:solidFill>
-                <a:latin typeface="Calibri"/>
-              </a:rPr>
-              <a:t> — Frontend : http://localhost:5173</a:t>
-            </a:r>
-          </a:p>
-          <a:p>
-            <a:pPr>
-              <a:spcBef>
-                <a:spcPts val="200"/>
-              </a:spcBef>
-              <a:spcAft>
-                <a:spcPts val="800"/>
-              </a:spcAft>
-            </a:pPr>
-            <a:r>
-              <a:rPr sz="2000" b="1" i="0">
-                <a:solidFill>
-                  <a:srgbClr val="0071E3"/>
-                </a:solidFill>
-                <a:latin typeface="Calibri"/>
-              </a:rPr>
-              <a:t>▸ </a:t>
-            </a:r>
-            <a:r>
-              <a:rPr sz="2000" b="0" i="0">
-                <a:solidFill>
-                  <a:srgbClr val="1D1D1F"/>
-                </a:solidFill>
-                <a:latin typeface="Calibri"/>
-              </a:rPr>
-              <a:t>Boutiques de démonstration prêtes à l'emploi (Makita, Transpalette, EventPro).</a:t>
-            </a:r>
-          </a:p>
-          <a:p>
-            <a:pPr>
-              <a:spcBef>
-                <a:spcPts val="200"/>
-              </a:spcBef>
-              <a:spcAft>
-                <a:spcPts val="800"/>
-              </a:spcAft>
-            </a:pPr>
-            <a:r>
-              <a:rPr sz="2000" b="1" i="0">
-                <a:solidFill>
-                  <a:srgbClr val="0071E3"/>
-                </a:solidFill>
-                <a:latin typeface="Calibri"/>
-              </a:rPr>
-              <a:t>▸ </a:t>
-            </a:r>
-            <a:r>
-              <a:rPr sz="2000" b="0" i="0">
-                <a:solidFill>
-                  <a:srgbClr val="1D1D1F"/>
-                </a:solidFill>
-                <a:latin typeface="Calibri"/>
-              </a:rPr>
-              <a:t>Code source versionné sur GitHub.</a:t>
-            </a:r>
-          </a:p>
-          <a:p>
-            <a:pPr>
-              <a:spcBef>
-                <a:spcPts val="200"/>
-              </a:spcBef>
-              <a:spcAft>
-                <a:spcPts val="800"/>
-              </a:spcAft>
-            </a:pPr>
-            <a:r>
-              <a:rPr sz="2000" b="1" i="0">
-                <a:solidFill>
-                  <a:srgbClr val="0071E3"/>
-                </a:solidFill>
-                <a:latin typeface="Calibri"/>
-              </a:rPr>
-              <a:t>▸ </a:t>
-            </a:r>
-            <a:r>
-              <a:rPr sz="2000" b="0" i="0">
-                <a:solidFill>
-                  <a:srgbClr val="1D1D1F"/>
-                </a:solidFill>
-                <a:latin typeface="Calibri"/>
-              </a:rPr>
-              <a:t>Démonstration en direct : connexion, catalogue, panier, location, facture PDF, rapports.</a:t>
+            <a:r>
+              <a:rPr sz="1800" b="0" i="0">
+                <a:solidFill>
+                  <a:srgbClr val="BFD7F2"/>
+                </a:solidFill>
+                <a:latin typeface="Calibri"/>
+              </a:rPr>
+              <a:t>Captures d'écran des principales vues</a:t>
             </a:r>
           </a:p>
         </p:txBody>
@@ -5893,7 +5690,7 @@
                 </a:solidFill>
                 <a:latin typeface="Calibri"/>
               </a:rPr>
-              <a:t>CONCLUSION</a:t>
+              <a:t>DÉMONSTRATION</a:t>
             </a:r>
           </a:p>
         </p:txBody>
@@ -5927,7 +5724,7 @@
                 </a:solidFill>
                 <a:latin typeface="Calibri"/>
               </a:rPr>
-              <a:t>Conclusion et perspectives</a:t>
+              <a:t>Page de connexion</a:t>
             </a:r>
           </a:p>
         </p:txBody>
@@ -5976,16 +5773,45 @@
           </a:p>
         </p:txBody>
       </p:sp>
-      <p:sp>
-        <p:nvSpPr>
-          <p:cNvPr id="6" name="TextBox 5"/>
+      <p:pic>
+        <p:nvPicPr>
+          <p:cNvPr id="6" name="Picture 5" descr="02-connexion.png"/>
+          <p:cNvPicPr>
+            <a:picLocks noChangeAspect="1"/>
+          </p:cNvPicPr>
+          <p:nvPr/>
+        </p:nvPicPr>
+        <p:blipFill>
+          <a:blip r:embed="rId2"/>
+          <a:stretch>
+            <a:fillRect/>
+          </a:stretch>
+        </p:blipFill>
+        <p:spPr>
+          <a:xfrm>
+            <a:off x="2255367" y="1691640"/>
+            <a:ext cx="7680960" cy="4800600"/>
+          </a:xfrm>
+          <a:prstGeom prst="rect">
+            <a:avLst/>
+          </a:prstGeom>
+          <a:ln w="9525">
+            <a:solidFill>
+              <a:srgbClr val="E0E0E6"/>
+            </a:solidFill>
+          </a:ln>
+        </p:spPr>
+      </p:pic>
+      <p:sp>
+        <p:nvSpPr>
+          <p:cNvPr id="7" name="TextBox 6"/>
           <p:cNvSpPr txBox="1"/>
           <p:nvPr/>
         </p:nvSpPr>
         <p:spPr>
           <a:xfrm>
-            <a:off x="731520" y="1828800"/>
-            <a:ext cx="10698480" cy="4572000"/>
+            <a:off x="640080" y="6355080"/>
+            <a:ext cx="10881360" cy="365760"/>
           </a:xfrm>
           <a:prstGeom prst="rect">
             <a:avLst/>
@@ -5998,199 +5824,15 @@
           </a:bodyPr>
           <a:lstStyle/>
           <a:p>
-            <a:pPr>
-              <a:spcBef>
-                <a:spcPts val="200"/>
-              </a:spcBef>
-              <a:spcAft>
-                <a:spcPts val="800"/>
-              </a:spcAft>
-            </a:pPr>
-            <a:r>
-              <a:rPr sz="2000" b="1" i="0">
-                <a:solidFill>
-                  <a:srgbClr val="0071E3"/>
-                </a:solidFill>
-                <a:latin typeface="Calibri"/>
-              </a:rPr>
-              <a:t>▸ </a:t>
-            </a:r>
-            <a:r>
-              <a:rPr sz="2000" b="0" i="0">
-                <a:solidFill>
-                  <a:srgbClr val="1D1D1F"/>
-                </a:solidFill>
-                <a:latin typeface="Calibri"/>
-              </a:rPr>
-              <a:t>Tous les objectifs ont été atteints : cycle complet de location, encaissements, PDF, multi-boutiques.</a:t>
-            </a:r>
-          </a:p>
-          <a:p>
-            <a:pPr>
-              <a:spcBef>
-                <a:spcPts val="200"/>
-              </a:spcBef>
-              <a:spcAft>
-                <a:spcPts val="800"/>
-              </a:spcAft>
-            </a:pPr>
-            <a:r>
-              <a:rPr sz="2000" b="1" i="0">
-                <a:solidFill>
-                  <a:srgbClr val="0071E3"/>
-                </a:solidFill>
-                <a:latin typeface="Calibri"/>
-              </a:rPr>
-              <a:t>▸ </a:t>
-            </a:r>
-            <a:r>
-              <a:rPr sz="2000" b="0" i="0">
-                <a:solidFill>
-                  <a:srgbClr val="1D1D1F"/>
-                </a:solidFill>
-                <a:latin typeface="Calibri"/>
-              </a:rPr>
-              <a:t>Maîtrise du développement full-stack (Laravel + React) et de la conception (MVC, base de données).</a:t>
-            </a:r>
-          </a:p>
-          <a:p>
-            <a:pPr lvl="1">
-              <a:spcBef>
-                <a:spcPts val="200"/>
-              </a:spcBef>
-              <a:spcAft>
-                <a:spcPts val="800"/>
-              </a:spcAft>
-            </a:pPr>
-            <a:r>
-              <a:rPr sz="2000" b="0" i="0">
+            <a:pPr algn="ctr"/>
+            <a:r>
+              <a:rPr sz="1200" b="0" i="1">
                 <a:solidFill>
                   <a:srgbClr val="6E6E73"/>
                 </a:solidFill>
                 <a:latin typeface="Calibri"/>
               </a:rPr>
-              <a:t>•  </a:t>
-            </a:r>
-            <a:r>
-              <a:rPr sz="1800" b="0" i="0">
-                <a:solidFill>
-                  <a:srgbClr val="1D1D1F"/>
-                </a:solidFill>
-                <a:latin typeface="Calibri"/>
-              </a:rPr>
-              <a:t>Perspectives :</a:t>
-            </a:r>
-          </a:p>
-          <a:p>
-            <a:pPr lvl="1">
-              <a:spcBef>
-                <a:spcPts val="200"/>
-              </a:spcBef>
-              <a:spcAft>
-                <a:spcPts val="800"/>
-              </a:spcAft>
-            </a:pPr>
-            <a:r>
-              <a:rPr sz="2000" b="0" i="0">
-                <a:solidFill>
-                  <a:srgbClr val="6E6E73"/>
-                </a:solidFill>
-                <a:latin typeface="Calibri"/>
-              </a:rPr>
-              <a:t>•  </a:t>
-            </a:r>
-            <a:r>
-              <a:rPr sz="1800" b="0" i="0">
-                <a:solidFill>
-                  <a:srgbClr val="1D1D1F"/>
-                </a:solidFill>
-                <a:latin typeface="Calibri"/>
-              </a:rPr>
-              <a:t>Paiement en ligne (CMI / Stripe).</a:t>
-            </a:r>
-          </a:p>
-          <a:p>
-            <a:pPr lvl="1">
-              <a:spcBef>
-                <a:spcPts val="200"/>
-              </a:spcBef>
-              <a:spcAft>
-                <a:spcPts val="800"/>
-              </a:spcAft>
-            </a:pPr>
-            <a:r>
-              <a:rPr sz="2000" b="0" i="0">
-                <a:solidFill>
-                  <a:srgbClr val="6E6E73"/>
-                </a:solidFill>
-                <a:latin typeface="Calibri"/>
-              </a:rPr>
-              <a:t>•  </a:t>
-            </a:r>
-            <a:r>
-              <a:rPr sz="1800" b="0" i="0">
-                <a:solidFill>
-                  <a:srgbClr val="1D1D1F"/>
-                </a:solidFill>
-                <a:latin typeface="Calibri"/>
-              </a:rPr>
-              <a:t>Notifications automatiques (rappels de retour).</a:t>
-            </a:r>
-          </a:p>
-          <a:p>
-            <a:pPr lvl="1">
-              <a:spcBef>
-                <a:spcPts val="200"/>
-              </a:spcBef>
-              <a:spcAft>
-                <a:spcPts val="800"/>
-              </a:spcAft>
-            </a:pPr>
-            <a:r>
-              <a:rPr sz="2000" b="0" i="0">
-                <a:solidFill>
-                  <a:srgbClr val="6E6E73"/>
-                </a:solidFill>
-                <a:latin typeface="Calibri"/>
-              </a:rPr>
-              <a:t>•  </a:t>
-            </a:r>
-            <a:r>
-              <a:rPr sz="1800" b="0" i="0">
-                <a:solidFill>
-                  <a:srgbClr val="1D1D1F"/>
-                </a:solidFill>
-                <a:latin typeface="Calibri"/>
-              </a:rPr>
-              <a:t>Application mobile native.</a:t>
-            </a:r>
-          </a:p>
-          <a:p>
-            <a:pPr lvl="1">
-              <a:spcBef>
-                <a:spcPts val="200"/>
-              </a:spcBef>
-              <a:spcAft>
-                <a:spcPts val="800"/>
-              </a:spcAft>
-            </a:pPr>
-            <a:r>
-              <a:rPr sz="2000" b="0" i="0">
-                <a:solidFill>
-                  <a:srgbClr val="6E6E73"/>
-                </a:solidFill>
-                <a:latin typeface="Calibri"/>
-              </a:rPr>
-              <a:t>•  </a:t>
-            </a:r>
-            <a:r>
-              <a:rPr sz="1800" b="0" i="0">
-                <a:solidFill>
-                  <a:srgbClr val="1D1D1F"/>
-                </a:solidFill>
-                <a:latin typeface="Calibri"/>
-              </a:rPr>
-              <a:t>Export des rapports (PDF / Excel).</a:t>
+              <a:t>Connexion et navigation publique (Accueil, Boutiques, langue FR/AR)</a:t>
             </a:r>
           </a:p>
         </p:txBody>
@@ -6209,7 +5851,7 @@
     <p:bg>
       <p:bgPr>
         <a:solidFill>
-          <a:srgbClr val="0A2540"/>
+          <a:srgbClr val="FFFFFF"/>
         </a:solidFill>
         <a:effectLst/>
       </p:bgPr>
@@ -6230,7 +5872,7 @@
         <p:spPr>
           <a:xfrm>
             <a:off x="0" y="0"/>
-            <a:ext cx="12191695" cy="201168"/>
+            <a:ext cx="12191695" cy="164592"/>
           </a:xfrm>
           <a:prstGeom prst="rect">
             <a:avLst/>
@@ -6265,9 +5907,121 @@
           </a:p>
         </p:txBody>
       </p:sp>
+      <p:sp>
+        <p:nvSpPr>
+          <p:cNvPr id="3" name="TextBox 2"/>
+          <p:cNvSpPr txBox="1"/>
+          <p:nvPr/>
+        </p:nvSpPr>
+        <p:spPr>
+          <a:xfrm>
+            <a:off x="640080" y="502920"/>
+            <a:ext cx="10881360" cy="365760"/>
+          </a:xfrm>
+          <a:prstGeom prst="rect">
+            <a:avLst/>
+          </a:prstGeom>
+          <a:noFill/>
+        </p:spPr>
+        <p:txBody>
+          <a:bodyPr wrap="square">
+            <a:spAutoFit/>
+          </a:bodyPr>
+          <a:lstStyle/>
+          <a:p>
+            <a:r>
+              <a:rPr sz="1200" b="1" i="0">
+                <a:solidFill>
+                  <a:srgbClr val="0071E3"/>
+                </a:solidFill>
+                <a:latin typeface="Calibri"/>
+              </a:rPr>
+              <a:t>DÉMONSTRATION</a:t>
+            </a:r>
+          </a:p>
+        </p:txBody>
+      </p:sp>
+      <p:sp>
+        <p:nvSpPr>
+          <p:cNvPr id="4" name="TextBox 3"/>
+          <p:cNvSpPr txBox="1"/>
+          <p:nvPr/>
+        </p:nvSpPr>
+        <p:spPr>
+          <a:xfrm>
+            <a:off x="640080" y="777240"/>
+            <a:ext cx="10881360" cy="822960"/>
+          </a:xfrm>
+          <a:prstGeom prst="rect">
+            <a:avLst/>
+          </a:prstGeom>
+          <a:noFill/>
+        </p:spPr>
+        <p:txBody>
+          <a:bodyPr wrap="square">
+            <a:spAutoFit/>
+          </a:bodyPr>
+          <a:lstStyle/>
+          <a:p>
+            <a:r>
+              <a:rPr sz="3000" b="1" i="0">
+                <a:solidFill>
+                  <a:srgbClr val="0A2540"/>
+                </a:solidFill>
+                <a:latin typeface="Calibri"/>
+              </a:rPr>
+              <a:t>Boutiques publiques</a:t>
+            </a:r>
+          </a:p>
+        </p:txBody>
+      </p:sp>
+      <p:sp>
+        <p:nvSpPr>
+          <p:cNvPr id="5" name="Rectangle 4"/>
+          <p:cNvSpPr/>
+          <p:nvPr/>
+        </p:nvSpPr>
+        <p:spPr>
+          <a:xfrm>
+            <a:off x="658368" y="1481328"/>
+            <a:ext cx="1005840" cy="45720"/>
+          </a:xfrm>
+          <a:prstGeom prst="rect">
+            <a:avLst/>
+          </a:prstGeom>
+          <a:solidFill>
+            <a:srgbClr val="0071E3"/>
+          </a:solidFill>
+          <a:ln>
+            <a:noFill/>
+          </a:ln>
+          <a:effectLst/>
+        </p:spPr>
+        <p:style>
+          <a:lnRef idx="1">
+            <a:schemeClr val="accent1"/>
+          </a:lnRef>
+          <a:fillRef idx="3">
+            <a:schemeClr val="accent1"/>
+          </a:fillRef>
+          <a:effectRef idx="2">
+            <a:schemeClr val="accent1"/>
+          </a:effectRef>
+          <a:fontRef idx="minor">
+            <a:schemeClr val="lt1"/>
+          </a:fontRef>
+        </p:style>
+        <p:txBody>
+          <a:bodyPr rtlCol="0" anchor="ctr"/>
+          <a:lstStyle/>
+          <a:p>
+            <a:pPr algn="ctr"/>
+          </a:p>
+        </p:txBody>
+      </p:sp>
       <p:pic>
         <p:nvPicPr>
-          <p:cNvPr id="3" name="Picture 2" descr="logo.png"/>
+          <p:cNvPr id="6" name="Picture 5" descr="03-boutiques.png"/>
           <p:cNvPicPr>
             <a:picLocks noChangeAspect="1"/>
           </p:cNvPicPr>
@@ -6281,24 +6035,29 @@
         </p:blipFill>
         <p:spPr>
           <a:xfrm>
-            <a:off x="4926722" y="1828800"/>
-            <a:ext cx="2338251" cy="1463040"/>
-          </a:xfrm>
-          <a:prstGeom prst="rect">
-            <a:avLst/>
-          </a:prstGeom>
+            <a:off x="2255367" y="1691640"/>
+            <a:ext cx="7680960" cy="4800600"/>
+          </a:xfrm>
+          <a:prstGeom prst="rect">
+            <a:avLst/>
+          </a:prstGeom>
+          <a:ln w="9525">
+            <a:solidFill>
+              <a:srgbClr val="E0E0E6"/>
+            </a:solidFill>
+          </a:ln>
         </p:spPr>
       </p:pic>
       <p:sp>
         <p:nvSpPr>
-          <p:cNvPr id="4" name="TextBox 3"/>
+          <p:cNvPr id="7" name="TextBox 6"/>
           <p:cNvSpPr txBox="1"/>
           <p:nvPr/>
         </p:nvSpPr>
         <p:spPr>
           <a:xfrm>
-            <a:off x="914400" y="3566160"/>
-            <a:ext cx="10360152" cy="914400"/>
+            <a:off x="640080" y="6355080"/>
+            <a:ext cx="10881360" cy="365760"/>
           </a:xfrm>
           <a:prstGeom prst="rect">
             <a:avLst/>
@@ -6313,27 +6072,97 @@
           <a:p>
             <a:pPr algn="ctr"/>
             <a:r>
-              <a:rPr sz="3600" b="1" i="0">
-                <a:solidFill>
-                  <a:srgbClr val="FFFFFF"/>
-                </a:solidFill>
-                <a:latin typeface="Calibri"/>
-              </a:rPr>
-              <a:t>Merci de votre attention</a:t>
-            </a:r>
-          </a:p>
-        </p:txBody>
-      </p:sp>
-      <p:sp>
-        <p:nvSpPr>
-          <p:cNvPr id="5" name="TextBox 4"/>
+              <a:rPr sz="1200" b="0" i="1">
+                <a:solidFill>
+                  <a:srgbClr val="6E6E73"/>
+                </a:solidFill>
+                <a:latin typeface="Calibri"/>
+              </a:rPr>
+              <a:t>Vitrine : liste des boutiques disponibles</a:t>
+            </a:r>
+          </a:p>
+        </p:txBody>
+      </p:sp>
+    </p:spTree>
+  </p:cSld>
+  <p:clrMapOvr>
+    <a:masterClrMapping/>
+  </p:clrMapOvr>
+</p:sld>
+</file>
+
+<file path=ppt/slides/slide18.xml><?xml version="1.0" encoding="utf-8"?>
+<p:sld xmlns:a="http://schemas.openxmlformats.org/drawingml/2006/main" xmlns:p="http://schemas.openxmlformats.org/presentationml/2006/main" xmlns:r="http://schemas.openxmlformats.org/officeDocument/2006/relationships">
+  <p:cSld>
+    <p:bg>
+      <p:bgPr>
+        <a:solidFill>
+          <a:srgbClr val="FFFFFF"/>
+        </a:solidFill>
+        <a:effectLst/>
+      </p:bgPr>
+    </p:bg>
+    <p:spTree>
+      <p:nvGrpSpPr>
+        <p:cNvPr id="1" name=""/>
+        <p:cNvGrpSpPr/>
+        <p:nvPr/>
+      </p:nvGrpSpPr>
+      <p:grpSpPr/>
+      <p:sp>
+        <p:nvSpPr>
+          <p:cNvPr id="2" name="Rectangle 1"/>
+          <p:cNvSpPr/>
+          <p:nvPr/>
+        </p:nvSpPr>
+        <p:spPr>
+          <a:xfrm>
+            <a:off x="0" y="0"/>
+            <a:ext cx="12191695" cy="164592"/>
+          </a:xfrm>
+          <a:prstGeom prst="rect">
+            <a:avLst/>
+          </a:prstGeom>
+          <a:solidFill>
+            <a:srgbClr val="0071E3"/>
+          </a:solidFill>
+          <a:ln>
+            <a:noFill/>
+          </a:ln>
+          <a:effectLst/>
+        </p:spPr>
+        <p:style>
+          <a:lnRef idx="1">
+            <a:schemeClr val="accent1"/>
+          </a:lnRef>
+          <a:fillRef idx="3">
+            <a:schemeClr val="accent1"/>
+          </a:fillRef>
+          <a:effectRef idx="2">
+            <a:schemeClr val="accent1"/>
+          </a:effectRef>
+          <a:fontRef idx="minor">
+            <a:schemeClr val="lt1"/>
+          </a:fontRef>
+        </p:style>
+        <p:txBody>
+          <a:bodyPr rtlCol="0" anchor="ctr"/>
+          <a:lstStyle/>
+          <a:p>
+            <a:pPr algn="ctr"/>
+          </a:p>
+        </p:txBody>
+      </p:sp>
+      <p:sp>
+        <p:nvSpPr>
+          <p:cNvPr id="3" name="TextBox 2"/>
           <p:cNvSpPr txBox="1"/>
           <p:nvPr/>
         </p:nvSpPr>
         <p:spPr>
           <a:xfrm>
-            <a:off x="914400" y="4480560"/>
-            <a:ext cx="10360152" cy="548640"/>
+            <a:off x="640080" y="502920"/>
+            <a:ext cx="10881360" cy="365760"/>
           </a:xfrm>
           <a:prstGeom prst="rect">
             <a:avLst/>
@@ -6346,15 +6175,402 @@
           </a:bodyPr>
           <a:lstStyle/>
           <a:p>
+            <a:r>
+              <a:rPr sz="1200" b="1" i="0">
+                <a:solidFill>
+                  <a:srgbClr val="0071E3"/>
+                </a:solidFill>
+                <a:latin typeface="Calibri"/>
+              </a:rPr>
+              <a:t>DÉMONSTRATION</a:t>
+            </a:r>
+          </a:p>
+        </p:txBody>
+      </p:sp>
+      <p:sp>
+        <p:nvSpPr>
+          <p:cNvPr id="4" name="TextBox 3"/>
+          <p:cNvSpPr txBox="1"/>
+          <p:nvPr/>
+        </p:nvSpPr>
+        <p:spPr>
+          <a:xfrm>
+            <a:off x="640080" y="777240"/>
+            <a:ext cx="10881360" cy="822960"/>
+          </a:xfrm>
+          <a:prstGeom prst="rect">
+            <a:avLst/>
+          </a:prstGeom>
+          <a:noFill/>
+        </p:spPr>
+        <p:txBody>
+          <a:bodyPr wrap="square">
+            <a:spAutoFit/>
+          </a:bodyPr>
+          <a:lstStyle/>
+          <a:p>
+            <a:r>
+              <a:rPr sz="3000" b="1" i="0">
+                <a:solidFill>
+                  <a:srgbClr val="0A2540"/>
+                </a:solidFill>
+                <a:latin typeface="Calibri"/>
+              </a:rPr>
+              <a:t>Tableau de bord</a:t>
+            </a:r>
+          </a:p>
+        </p:txBody>
+      </p:sp>
+      <p:sp>
+        <p:nvSpPr>
+          <p:cNvPr id="5" name="Rectangle 4"/>
+          <p:cNvSpPr/>
+          <p:nvPr/>
+        </p:nvSpPr>
+        <p:spPr>
+          <a:xfrm>
+            <a:off x="658368" y="1481328"/>
+            <a:ext cx="1005840" cy="45720"/>
+          </a:xfrm>
+          <a:prstGeom prst="rect">
+            <a:avLst/>
+          </a:prstGeom>
+          <a:solidFill>
+            <a:srgbClr val="0071E3"/>
+          </a:solidFill>
+          <a:ln>
+            <a:noFill/>
+          </a:ln>
+          <a:effectLst/>
+        </p:spPr>
+        <p:style>
+          <a:lnRef idx="1">
+            <a:schemeClr val="accent1"/>
+          </a:lnRef>
+          <a:fillRef idx="3">
+            <a:schemeClr val="accent1"/>
+          </a:fillRef>
+          <a:effectRef idx="2">
+            <a:schemeClr val="accent1"/>
+          </a:effectRef>
+          <a:fontRef idx="minor">
+            <a:schemeClr val="lt1"/>
+          </a:fontRef>
+        </p:style>
+        <p:txBody>
+          <a:bodyPr rtlCol="0" anchor="ctr"/>
+          <a:lstStyle/>
+          <a:p>
             <a:pPr algn="ctr"/>
-            <a:r>
-              <a:rPr sz="2000" b="0" i="0">
-                <a:solidFill>
-                  <a:srgbClr val="BFD7F2"/>
-                </a:solidFill>
-                <a:latin typeface="Calibri"/>
-              </a:rPr>
-              <a:t>Questions &amp; discussion</a:t>
+          </a:p>
+        </p:txBody>
+      </p:sp>
+      <p:pic>
+        <p:nvPicPr>
+          <p:cNvPr id="6" name="Picture 5" descr="04-tableau-bord.png"/>
+          <p:cNvPicPr>
+            <a:picLocks noChangeAspect="1"/>
+          </p:cNvPicPr>
+          <p:nvPr/>
+        </p:nvPicPr>
+        <p:blipFill>
+          <a:blip r:embed="rId2"/>
+          <a:stretch>
+            <a:fillRect/>
+          </a:stretch>
+        </p:blipFill>
+        <p:spPr>
+          <a:xfrm>
+            <a:off x="2255367" y="1691640"/>
+            <a:ext cx="7680960" cy="4800600"/>
+          </a:xfrm>
+          <a:prstGeom prst="rect">
+            <a:avLst/>
+          </a:prstGeom>
+          <a:ln w="9525">
+            <a:solidFill>
+              <a:srgbClr val="E0E0E6"/>
+            </a:solidFill>
+          </a:ln>
+        </p:spPr>
+      </p:pic>
+      <p:sp>
+        <p:nvSpPr>
+          <p:cNvPr id="7" name="TextBox 6"/>
+          <p:cNvSpPr txBox="1"/>
+          <p:nvPr/>
+        </p:nvSpPr>
+        <p:spPr>
+          <a:xfrm>
+            <a:off x="640080" y="6355080"/>
+            <a:ext cx="10881360" cy="365760"/>
+          </a:xfrm>
+          <a:prstGeom prst="rect">
+            <a:avLst/>
+          </a:prstGeom>
+          <a:noFill/>
+        </p:spPr>
+        <p:txBody>
+          <a:bodyPr wrap="square">
+            <a:spAutoFit/>
+          </a:bodyPr>
+          <a:lstStyle/>
+          <a:p>
+            <a:pPr algn="ctr"/>
+            <a:r>
+              <a:rPr sz="1200" b="0" i="1">
+                <a:solidFill>
+                  <a:srgbClr val="6E6E73"/>
+                </a:solidFill>
+                <a:latin typeface="Calibri"/>
+              </a:rPr>
+              <a:t>Indicateurs clés + tableau Kanban des locations (glisser-déposer)</a:t>
+            </a:r>
+          </a:p>
+        </p:txBody>
+      </p:sp>
+    </p:spTree>
+  </p:cSld>
+  <p:clrMapOvr>
+    <a:masterClrMapping/>
+  </p:clrMapOvr>
+</p:sld>
+</file>
+
+<file path=ppt/slides/slide19.xml><?xml version="1.0" encoding="utf-8"?>
+<p:sld xmlns:a="http://schemas.openxmlformats.org/drawingml/2006/main" xmlns:p="http://schemas.openxmlformats.org/presentationml/2006/main" xmlns:r="http://schemas.openxmlformats.org/officeDocument/2006/relationships">
+  <p:cSld>
+    <p:bg>
+      <p:bgPr>
+        <a:solidFill>
+          <a:srgbClr val="FFFFFF"/>
+        </a:solidFill>
+        <a:effectLst/>
+      </p:bgPr>
+    </p:bg>
+    <p:spTree>
+      <p:nvGrpSpPr>
+        <p:cNvPr id="1" name=""/>
+        <p:cNvGrpSpPr/>
+        <p:nvPr/>
+      </p:nvGrpSpPr>
+      <p:grpSpPr/>
+      <p:sp>
+        <p:nvSpPr>
+          <p:cNvPr id="2" name="Rectangle 1"/>
+          <p:cNvSpPr/>
+          <p:nvPr/>
+        </p:nvSpPr>
+        <p:spPr>
+          <a:xfrm>
+            <a:off x="0" y="0"/>
+            <a:ext cx="12191695" cy="164592"/>
+          </a:xfrm>
+          <a:prstGeom prst="rect">
+            <a:avLst/>
+          </a:prstGeom>
+          <a:solidFill>
+            <a:srgbClr val="0071E3"/>
+          </a:solidFill>
+          <a:ln>
+            <a:noFill/>
+          </a:ln>
+          <a:effectLst/>
+        </p:spPr>
+        <p:style>
+          <a:lnRef idx="1">
+            <a:schemeClr val="accent1"/>
+          </a:lnRef>
+          <a:fillRef idx="3">
+            <a:schemeClr val="accent1"/>
+          </a:fillRef>
+          <a:effectRef idx="2">
+            <a:schemeClr val="accent1"/>
+          </a:effectRef>
+          <a:fontRef idx="minor">
+            <a:schemeClr val="lt1"/>
+          </a:fontRef>
+        </p:style>
+        <p:txBody>
+          <a:bodyPr rtlCol="0" anchor="ctr"/>
+          <a:lstStyle/>
+          <a:p>
+            <a:pPr algn="ctr"/>
+          </a:p>
+        </p:txBody>
+      </p:sp>
+      <p:sp>
+        <p:nvSpPr>
+          <p:cNvPr id="3" name="TextBox 2"/>
+          <p:cNvSpPr txBox="1"/>
+          <p:nvPr/>
+        </p:nvSpPr>
+        <p:spPr>
+          <a:xfrm>
+            <a:off x="640080" y="502920"/>
+            <a:ext cx="10881360" cy="365760"/>
+          </a:xfrm>
+          <a:prstGeom prst="rect">
+            <a:avLst/>
+          </a:prstGeom>
+          <a:noFill/>
+        </p:spPr>
+        <p:txBody>
+          <a:bodyPr wrap="square">
+            <a:spAutoFit/>
+          </a:bodyPr>
+          <a:lstStyle/>
+          <a:p>
+            <a:r>
+              <a:rPr sz="1200" b="1" i="0">
+                <a:solidFill>
+                  <a:srgbClr val="0071E3"/>
+                </a:solidFill>
+                <a:latin typeface="Calibri"/>
+              </a:rPr>
+              <a:t>DÉMONSTRATION</a:t>
+            </a:r>
+          </a:p>
+        </p:txBody>
+      </p:sp>
+      <p:sp>
+        <p:nvSpPr>
+          <p:cNvPr id="4" name="TextBox 3"/>
+          <p:cNvSpPr txBox="1"/>
+          <p:nvPr/>
+        </p:nvSpPr>
+        <p:spPr>
+          <a:xfrm>
+            <a:off x="640080" y="777240"/>
+            <a:ext cx="10881360" cy="822960"/>
+          </a:xfrm>
+          <a:prstGeom prst="rect">
+            <a:avLst/>
+          </a:prstGeom>
+          <a:noFill/>
+        </p:spPr>
+        <p:txBody>
+          <a:bodyPr wrap="square">
+            <a:spAutoFit/>
+          </a:bodyPr>
+          <a:lstStyle/>
+          <a:p>
+            <a:r>
+              <a:rPr sz="3000" b="1" i="0">
+                <a:solidFill>
+                  <a:srgbClr val="0A2540"/>
+                </a:solidFill>
+                <a:latin typeface="Calibri"/>
+              </a:rPr>
+              <a:t>Catalogue du matériel</a:t>
+            </a:r>
+          </a:p>
+        </p:txBody>
+      </p:sp>
+      <p:sp>
+        <p:nvSpPr>
+          <p:cNvPr id="5" name="Rectangle 4"/>
+          <p:cNvSpPr/>
+          <p:nvPr/>
+        </p:nvSpPr>
+        <p:spPr>
+          <a:xfrm>
+            <a:off x="658368" y="1481328"/>
+            <a:ext cx="1005840" cy="45720"/>
+          </a:xfrm>
+          <a:prstGeom prst="rect">
+            <a:avLst/>
+          </a:prstGeom>
+          <a:solidFill>
+            <a:srgbClr val="0071E3"/>
+          </a:solidFill>
+          <a:ln>
+            <a:noFill/>
+          </a:ln>
+          <a:effectLst/>
+        </p:spPr>
+        <p:style>
+          <a:lnRef idx="1">
+            <a:schemeClr val="accent1"/>
+          </a:lnRef>
+          <a:fillRef idx="3">
+            <a:schemeClr val="accent1"/>
+          </a:fillRef>
+          <a:effectRef idx="2">
+            <a:schemeClr val="accent1"/>
+          </a:effectRef>
+          <a:fontRef idx="minor">
+            <a:schemeClr val="lt1"/>
+          </a:fontRef>
+        </p:style>
+        <p:txBody>
+          <a:bodyPr rtlCol="0" anchor="ctr"/>
+          <a:lstStyle/>
+          <a:p>
+            <a:pPr algn="ctr"/>
+          </a:p>
+        </p:txBody>
+      </p:sp>
+      <p:pic>
+        <p:nvPicPr>
+          <p:cNvPr id="6" name="Picture 5" descr="05-materiels.png"/>
+          <p:cNvPicPr>
+            <a:picLocks noChangeAspect="1"/>
+          </p:cNvPicPr>
+          <p:nvPr/>
+        </p:nvPicPr>
+        <p:blipFill>
+          <a:blip r:embed="rId2"/>
+          <a:stretch>
+            <a:fillRect/>
+          </a:stretch>
+        </p:blipFill>
+        <p:spPr>
+          <a:xfrm>
+            <a:off x="2255367" y="1691640"/>
+            <a:ext cx="7680960" cy="4800600"/>
+          </a:xfrm>
+          <a:prstGeom prst="rect">
+            <a:avLst/>
+          </a:prstGeom>
+          <a:ln w="9525">
+            <a:solidFill>
+              <a:srgbClr val="E0E0E6"/>
+            </a:solidFill>
+          </a:ln>
+        </p:spPr>
+      </p:pic>
+      <p:sp>
+        <p:nvSpPr>
+          <p:cNvPr id="7" name="TextBox 6"/>
+          <p:cNvSpPr txBox="1"/>
+          <p:nvPr/>
+        </p:nvSpPr>
+        <p:spPr>
+          <a:xfrm>
+            <a:off x="640080" y="6355080"/>
+            <a:ext cx="10881360" cy="365760"/>
+          </a:xfrm>
+          <a:prstGeom prst="rect">
+            <a:avLst/>
+          </a:prstGeom>
+          <a:noFill/>
+        </p:spPr>
+        <p:txBody>
+          <a:bodyPr wrap="square">
+            <a:spAutoFit/>
+          </a:bodyPr>
+          <a:lstStyle/>
+          <a:p>
+            <a:pPr algn="ctr"/>
+            <a:r>
+              <a:rPr sz="1200" b="0" i="1">
+                <a:solidFill>
+                  <a:srgbClr val="6E6E73"/>
+                </a:solidFill>
+                <a:latin typeface="Calibri"/>
+              </a:rPr>
+              <a:t>Inventaire : catégorie, marque, prix/jour, stock, disponibilité</a:t>
             </a:r>
           </a:p>
         </p:txBody>
@@ -6824,6 +7040,2401 @@
 </p:sld>
 </file>
 
+<file path=ppt/slides/slide20.xml><?xml version="1.0" encoding="utf-8"?>
+<p:sld xmlns:a="http://schemas.openxmlformats.org/drawingml/2006/main" xmlns:p="http://schemas.openxmlformats.org/presentationml/2006/main" xmlns:r="http://schemas.openxmlformats.org/officeDocument/2006/relationships">
+  <p:cSld>
+    <p:bg>
+      <p:bgPr>
+        <a:solidFill>
+          <a:srgbClr val="FFFFFF"/>
+        </a:solidFill>
+        <a:effectLst/>
+      </p:bgPr>
+    </p:bg>
+    <p:spTree>
+      <p:nvGrpSpPr>
+        <p:cNvPr id="1" name=""/>
+        <p:cNvGrpSpPr/>
+        <p:nvPr/>
+      </p:nvGrpSpPr>
+      <p:grpSpPr/>
+      <p:sp>
+        <p:nvSpPr>
+          <p:cNvPr id="2" name="Rectangle 1"/>
+          <p:cNvSpPr/>
+          <p:nvPr/>
+        </p:nvSpPr>
+        <p:spPr>
+          <a:xfrm>
+            <a:off x="0" y="0"/>
+            <a:ext cx="12191695" cy="164592"/>
+          </a:xfrm>
+          <a:prstGeom prst="rect">
+            <a:avLst/>
+          </a:prstGeom>
+          <a:solidFill>
+            <a:srgbClr val="0071E3"/>
+          </a:solidFill>
+          <a:ln>
+            <a:noFill/>
+          </a:ln>
+          <a:effectLst/>
+        </p:spPr>
+        <p:style>
+          <a:lnRef idx="1">
+            <a:schemeClr val="accent1"/>
+          </a:lnRef>
+          <a:fillRef idx="3">
+            <a:schemeClr val="accent1"/>
+          </a:fillRef>
+          <a:effectRef idx="2">
+            <a:schemeClr val="accent1"/>
+          </a:effectRef>
+          <a:fontRef idx="minor">
+            <a:schemeClr val="lt1"/>
+          </a:fontRef>
+        </p:style>
+        <p:txBody>
+          <a:bodyPr rtlCol="0" anchor="ctr"/>
+          <a:lstStyle/>
+          <a:p>
+            <a:pPr algn="ctr"/>
+          </a:p>
+        </p:txBody>
+      </p:sp>
+      <p:sp>
+        <p:nvSpPr>
+          <p:cNvPr id="3" name="TextBox 2"/>
+          <p:cNvSpPr txBox="1"/>
+          <p:nvPr/>
+        </p:nvSpPr>
+        <p:spPr>
+          <a:xfrm>
+            <a:off x="640080" y="502920"/>
+            <a:ext cx="10881360" cy="365760"/>
+          </a:xfrm>
+          <a:prstGeom prst="rect">
+            <a:avLst/>
+          </a:prstGeom>
+          <a:noFill/>
+        </p:spPr>
+        <p:txBody>
+          <a:bodyPr wrap="square">
+            <a:spAutoFit/>
+          </a:bodyPr>
+          <a:lstStyle/>
+          <a:p>
+            <a:r>
+              <a:rPr sz="1200" b="1" i="0">
+                <a:solidFill>
+                  <a:srgbClr val="0071E3"/>
+                </a:solidFill>
+                <a:latin typeface="Calibri"/>
+              </a:rPr>
+              <a:t>DÉMONSTRATION</a:t>
+            </a:r>
+          </a:p>
+        </p:txBody>
+      </p:sp>
+      <p:sp>
+        <p:nvSpPr>
+          <p:cNvPr id="4" name="TextBox 3"/>
+          <p:cNvSpPr txBox="1"/>
+          <p:nvPr/>
+        </p:nvSpPr>
+        <p:spPr>
+          <a:xfrm>
+            <a:off x="640080" y="777240"/>
+            <a:ext cx="10881360" cy="822960"/>
+          </a:xfrm>
+          <a:prstGeom prst="rect">
+            <a:avLst/>
+          </a:prstGeom>
+          <a:noFill/>
+        </p:spPr>
+        <p:txBody>
+          <a:bodyPr wrap="square">
+            <a:spAutoFit/>
+          </a:bodyPr>
+          <a:lstStyle/>
+          <a:p>
+            <a:r>
+              <a:rPr sz="3000" b="1" i="0">
+                <a:solidFill>
+                  <a:srgbClr val="0A2540"/>
+                </a:solidFill>
+                <a:latin typeface="Calibri"/>
+              </a:rPr>
+              <a:t>Gestion des locations</a:t>
+            </a:r>
+          </a:p>
+        </p:txBody>
+      </p:sp>
+      <p:sp>
+        <p:nvSpPr>
+          <p:cNvPr id="5" name="Rectangle 4"/>
+          <p:cNvSpPr/>
+          <p:nvPr/>
+        </p:nvSpPr>
+        <p:spPr>
+          <a:xfrm>
+            <a:off x="658368" y="1481328"/>
+            <a:ext cx="1005840" cy="45720"/>
+          </a:xfrm>
+          <a:prstGeom prst="rect">
+            <a:avLst/>
+          </a:prstGeom>
+          <a:solidFill>
+            <a:srgbClr val="0071E3"/>
+          </a:solidFill>
+          <a:ln>
+            <a:noFill/>
+          </a:ln>
+          <a:effectLst/>
+        </p:spPr>
+        <p:style>
+          <a:lnRef idx="1">
+            <a:schemeClr val="accent1"/>
+          </a:lnRef>
+          <a:fillRef idx="3">
+            <a:schemeClr val="accent1"/>
+          </a:fillRef>
+          <a:effectRef idx="2">
+            <a:schemeClr val="accent1"/>
+          </a:effectRef>
+          <a:fontRef idx="minor">
+            <a:schemeClr val="lt1"/>
+          </a:fontRef>
+        </p:style>
+        <p:txBody>
+          <a:bodyPr rtlCol="0" anchor="ctr"/>
+          <a:lstStyle/>
+          <a:p>
+            <a:pPr algn="ctr"/>
+          </a:p>
+        </p:txBody>
+      </p:sp>
+      <p:pic>
+        <p:nvPicPr>
+          <p:cNvPr id="6" name="Picture 5" descr="06-locations.png"/>
+          <p:cNvPicPr>
+            <a:picLocks noChangeAspect="1"/>
+          </p:cNvPicPr>
+          <p:nvPr/>
+        </p:nvPicPr>
+        <p:blipFill>
+          <a:blip r:embed="rId2"/>
+          <a:stretch>
+            <a:fillRect/>
+          </a:stretch>
+        </p:blipFill>
+        <p:spPr>
+          <a:xfrm>
+            <a:off x="2255367" y="1691640"/>
+            <a:ext cx="7680960" cy="4800600"/>
+          </a:xfrm>
+          <a:prstGeom prst="rect">
+            <a:avLst/>
+          </a:prstGeom>
+          <a:ln w="9525">
+            <a:solidFill>
+              <a:srgbClr val="E0E0E6"/>
+            </a:solidFill>
+          </a:ln>
+        </p:spPr>
+      </p:pic>
+      <p:sp>
+        <p:nvSpPr>
+          <p:cNvPr id="7" name="TextBox 6"/>
+          <p:cNvSpPr txBox="1"/>
+          <p:nvPr/>
+        </p:nvSpPr>
+        <p:spPr>
+          <a:xfrm>
+            <a:off x="640080" y="6355080"/>
+            <a:ext cx="10881360" cy="365760"/>
+          </a:xfrm>
+          <a:prstGeom prst="rect">
+            <a:avLst/>
+          </a:prstGeom>
+          <a:noFill/>
+        </p:spPr>
+        <p:txBody>
+          <a:bodyPr wrap="square">
+            <a:spAutoFit/>
+          </a:bodyPr>
+          <a:lstStyle/>
+          <a:p>
+            <a:pPr algn="ctr"/>
+            <a:r>
+              <a:rPr sz="1200" b="0" i="1">
+                <a:solidFill>
+                  <a:srgbClr val="6E6E73"/>
+                </a:solidFill>
+                <a:latin typeface="Calibri"/>
+              </a:rPr>
+              <a:t>Locations : TVA, statut de paiement, facture PDF</a:t>
+            </a:r>
+          </a:p>
+        </p:txBody>
+      </p:sp>
+    </p:spTree>
+  </p:cSld>
+  <p:clrMapOvr>
+    <a:masterClrMapping/>
+  </p:clrMapOvr>
+</p:sld>
+</file>
+
+<file path=ppt/slides/slide21.xml><?xml version="1.0" encoding="utf-8"?>
+<p:sld xmlns:a="http://schemas.openxmlformats.org/drawingml/2006/main" xmlns:p="http://schemas.openxmlformats.org/presentationml/2006/main" xmlns:r="http://schemas.openxmlformats.org/officeDocument/2006/relationships">
+  <p:cSld>
+    <p:bg>
+      <p:bgPr>
+        <a:solidFill>
+          <a:srgbClr val="FFFFFF"/>
+        </a:solidFill>
+        <a:effectLst/>
+      </p:bgPr>
+    </p:bg>
+    <p:spTree>
+      <p:nvGrpSpPr>
+        <p:cNvPr id="1" name=""/>
+        <p:cNvGrpSpPr/>
+        <p:nvPr/>
+      </p:nvGrpSpPr>
+      <p:grpSpPr/>
+      <p:sp>
+        <p:nvSpPr>
+          <p:cNvPr id="2" name="Rectangle 1"/>
+          <p:cNvSpPr/>
+          <p:nvPr/>
+        </p:nvSpPr>
+        <p:spPr>
+          <a:xfrm>
+            <a:off x="0" y="0"/>
+            <a:ext cx="12191695" cy="164592"/>
+          </a:xfrm>
+          <a:prstGeom prst="rect">
+            <a:avLst/>
+          </a:prstGeom>
+          <a:solidFill>
+            <a:srgbClr val="0071E3"/>
+          </a:solidFill>
+          <a:ln>
+            <a:noFill/>
+          </a:ln>
+          <a:effectLst/>
+        </p:spPr>
+        <p:style>
+          <a:lnRef idx="1">
+            <a:schemeClr val="accent1"/>
+          </a:lnRef>
+          <a:fillRef idx="3">
+            <a:schemeClr val="accent1"/>
+          </a:fillRef>
+          <a:effectRef idx="2">
+            <a:schemeClr val="accent1"/>
+          </a:effectRef>
+          <a:fontRef idx="minor">
+            <a:schemeClr val="lt1"/>
+          </a:fontRef>
+        </p:style>
+        <p:txBody>
+          <a:bodyPr rtlCol="0" anchor="ctr"/>
+          <a:lstStyle/>
+          <a:p>
+            <a:pPr algn="ctr"/>
+          </a:p>
+        </p:txBody>
+      </p:sp>
+      <p:sp>
+        <p:nvSpPr>
+          <p:cNvPr id="3" name="TextBox 2"/>
+          <p:cNvSpPr txBox="1"/>
+          <p:nvPr/>
+        </p:nvSpPr>
+        <p:spPr>
+          <a:xfrm>
+            <a:off x="640080" y="502920"/>
+            <a:ext cx="10881360" cy="365760"/>
+          </a:xfrm>
+          <a:prstGeom prst="rect">
+            <a:avLst/>
+          </a:prstGeom>
+          <a:noFill/>
+        </p:spPr>
+        <p:txBody>
+          <a:bodyPr wrap="square">
+            <a:spAutoFit/>
+          </a:bodyPr>
+          <a:lstStyle/>
+          <a:p>
+            <a:r>
+              <a:rPr sz="1200" b="1" i="0">
+                <a:solidFill>
+                  <a:srgbClr val="0071E3"/>
+                </a:solidFill>
+                <a:latin typeface="Calibri"/>
+              </a:rPr>
+              <a:t>DÉMONSTRATION</a:t>
+            </a:r>
+          </a:p>
+        </p:txBody>
+      </p:sp>
+      <p:sp>
+        <p:nvSpPr>
+          <p:cNvPr id="4" name="TextBox 3"/>
+          <p:cNvSpPr txBox="1"/>
+          <p:nvPr/>
+        </p:nvSpPr>
+        <p:spPr>
+          <a:xfrm>
+            <a:off x="640080" y="777240"/>
+            <a:ext cx="10881360" cy="822960"/>
+          </a:xfrm>
+          <a:prstGeom prst="rect">
+            <a:avLst/>
+          </a:prstGeom>
+          <a:noFill/>
+        </p:spPr>
+        <p:txBody>
+          <a:bodyPr wrap="square">
+            <a:spAutoFit/>
+          </a:bodyPr>
+          <a:lstStyle/>
+          <a:p>
+            <a:r>
+              <a:rPr sz="3000" b="1" i="0">
+                <a:solidFill>
+                  <a:srgbClr val="0A2540"/>
+                </a:solidFill>
+                <a:latin typeface="Calibri"/>
+              </a:rPr>
+              <a:t>Gestion des achats</a:t>
+            </a:r>
+          </a:p>
+        </p:txBody>
+      </p:sp>
+      <p:sp>
+        <p:nvSpPr>
+          <p:cNvPr id="5" name="Rectangle 4"/>
+          <p:cNvSpPr/>
+          <p:nvPr/>
+        </p:nvSpPr>
+        <p:spPr>
+          <a:xfrm>
+            <a:off x="658368" y="1481328"/>
+            <a:ext cx="1005840" cy="45720"/>
+          </a:xfrm>
+          <a:prstGeom prst="rect">
+            <a:avLst/>
+          </a:prstGeom>
+          <a:solidFill>
+            <a:srgbClr val="0071E3"/>
+          </a:solidFill>
+          <a:ln>
+            <a:noFill/>
+          </a:ln>
+          <a:effectLst/>
+        </p:spPr>
+        <p:style>
+          <a:lnRef idx="1">
+            <a:schemeClr val="accent1"/>
+          </a:lnRef>
+          <a:fillRef idx="3">
+            <a:schemeClr val="accent1"/>
+          </a:fillRef>
+          <a:effectRef idx="2">
+            <a:schemeClr val="accent1"/>
+          </a:effectRef>
+          <a:fontRef idx="minor">
+            <a:schemeClr val="lt1"/>
+          </a:fontRef>
+        </p:style>
+        <p:txBody>
+          <a:bodyPr rtlCol="0" anchor="ctr"/>
+          <a:lstStyle/>
+          <a:p>
+            <a:pPr algn="ctr"/>
+          </a:p>
+        </p:txBody>
+      </p:sp>
+      <p:pic>
+        <p:nvPicPr>
+          <p:cNvPr id="6" name="Picture 5" descr="07-achats.png"/>
+          <p:cNvPicPr>
+            <a:picLocks noChangeAspect="1"/>
+          </p:cNvPicPr>
+          <p:nvPr/>
+        </p:nvPicPr>
+        <p:blipFill>
+          <a:blip r:embed="rId2"/>
+          <a:stretch>
+            <a:fillRect/>
+          </a:stretch>
+        </p:blipFill>
+        <p:spPr>
+          <a:xfrm>
+            <a:off x="2255367" y="1691640"/>
+            <a:ext cx="7680960" cy="4800600"/>
+          </a:xfrm>
+          <a:prstGeom prst="rect">
+            <a:avLst/>
+          </a:prstGeom>
+          <a:ln w="9525">
+            <a:solidFill>
+              <a:srgbClr val="E0E0E6"/>
+            </a:solidFill>
+          </a:ln>
+        </p:spPr>
+      </p:pic>
+      <p:sp>
+        <p:nvSpPr>
+          <p:cNvPr id="7" name="TextBox 6"/>
+          <p:cNvSpPr txBox="1"/>
+          <p:nvPr/>
+        </p:nvSpPr>
+        <p:spPr>
+          <a:xfrm>
+            <a:off x="640080" y="6355080"/>
+            <a:ext cx="10881360" cy="365760"/>
+          </a:xfrm>
+          <a:prstGeom prst="rect">
+            <a:avLst/>
+          </a:prstGeom>
+          <a:noFill/>
+        </p:spPr>
+        <p:txBody>
+          <a:bodyPr wrap="square">
+            <a:spAutoFit/>
+          </a:bodyPr>
+          <a:lstStyle/>
+          <a:p>
+            <a:pPr algn="ctr"/>
+            <a:r>
+              <a:rPr sz="1200" b="0" i="1">
+                <a:solidFill>
+                  <a:srgbClr val="6E6E73"/>
+                </a:solidFill>
+                <a:latin typeface="Calibri"/>
+              </a:rPr>
+              <a:t>Approvisionnement : statut, réception, encaissements fournisseur</a:t>
+            </a:r>
+          </a:p>
+        </p:txBody>
+      </p:sp>
+    </p:spTree>
+  </p:cSld>
+  <p:clrMapOvr>
+    <a:masterClrMapping/>
+  </p:clrMapOvr>
+</p:sld>
+</file>
+
+<file path=ppt/slides/slide22.xml><?xml version="1.0" encoding="utf-8"?>
+<p:sld xmlns:a="http://schemas.openxmlformats.org/drawingml/2006/main" xmlns:p="http://schemas.openxmlformats.org/presentationml/2006/main" xmlns:r="http://schemas.openxmlformats.org/officeDocument/2006/relationships">
+  <p:cSld>
+    <p:bg>
+      <p:bgPr>
+        <a:solidFill>
+          <a:srgbClr val="FFFFFF"/>
+        </a:solidFill>
+        <a:effectLst/>
+      </p:bgPr>
+    </p:bg>
+    <p:spTree>
+      <p:nvGrpSpPr>
+        <p:cNvPr id="1" name=""/>
+        <p:cNvGrpSpPr/>
+        <p:nvPr/>
+      </p:nvGrpSpPr>
+      <p:grpSpPr/>
+      <p:sp>
+        <p:nvSpPr>
+          <p:cNvPr id="2" name="Rectangle 1"/>
+          <p:cNvSpPr/>
+          <p:nvPr/>
+        </p:nvSpPr>
+        <p:spPr>
+          <a:xfrm>
+            <a:off x="0" y="0"/>
+            <a:ext cx="12191695" cy="164592"/>
+          </a:xfrm>
+          <a:prstGeom prst="rect">
+            <a:avLst/>
+          </a:prstGeom>
+          <a:solidFill>
+            <a:srgbClr val="0071E3"/>
+          </a:solidFill>
+          <a:ln>
+            <a:noFill/>
+          </a:ln>
+          <a:effectLst/>
+        </p:spPr>
+        <p:style>
+          <a:lnRef idx="1">
+            <a:schemeClr val="accent1"/>
+          </a:lnRef>
+          <a:fillRef idx="3">
+            <a:schemeClr val="accent1"/>
+          </a:fillRef>
+          <a:effectRef idx="2">
+            <a:schemeClr val="accent1"/>
+          </a:effectRef>
+          <a:fontRef idx="minor">
+            <a:schemeClr val="lt1"/>
+          </a:fontRef>
+        </p:style>
+        <p:txBody>
+          <a:bodyPr rtlCol="0" anchor="ctr"/>
+          <a:lstStyle/>
+          <a:p>
+            <a:pPr algn="ctr"/>
+          </a:p>
+        </p:txBody>
+      </p:sp>
+      <p:sp>
+        <p:nvSpPr>
+          <p:cNvPr id="3" name="TextBox 2"/>
+          <p:cNvSpPr txBox="1"/>
+          <p:nvPr/>
+        </p:nvSpPr>
+        <p:spPr>
+          <a:xfrm>
+            <a:off x="640080" y="502920"/>
+            <a:ext cx="10881360" cy="365760"/>
+          </a:xfrm>
+          <a:prstGeom prst="rect">
+            <a:avLst/>
+          </a:prstGeom>
+          <a:noFill/>
+        </p:spPr>
+        <p:txBody>
+          <a:bodyPr wrap="square">
+            <a:spAutoFit/>
+          </a:bodyPr>
+          <a:lstStyle/>
+          <a:p>
+            <a:r>
+              <a:rPr sz="1200" b="1" i="0">
+                <a:solidFill>
+                  <a:srgbClr val="0071E3"/>
+                </a:solidFill>
+                <a:latin typeface="Calibri"/>
+              </a:rPr>
+              <a:t>DÉMONSTRATION</a:t>
+            </a:r>
+          </a:p>
+        </p:txBody>
+      </p:sp>
+      <p:sp>
+        <p:nvSpPr>
+          <p:cNvPr id="4" name="TextBox 3"/>
+          <p:cNvSpPr txBox="1"/>
+          <p:nvPr/>
+        </p:nvSpPr>
+        <p:spPr>
+          <a:xfrm>
+            <a:off x="640080" y="777240"/>
+            <a:ext cx="10881360" cy="822960"/>
+          </a:xfrm>
+          <a:prstGeom prst="rect">
+            <a:avLst/>
+          </a:prstGeom>
+          <a:noFill/>
+        </p:spPr>
+        <p:txBody>
+          <a:bodyPr wrap="square">
+            <a:spAutoFit/>
+          </a:bodyPr>
+          <a:lstStyle/>
+          <a:p>
+            <a:r>
+              <a:rPr sz="3000" b="1" i="0">
+                <a:solidFill>
+                  <a:srgbClr val="0A2540"/>
+                </a:solidFill>
+                <a:latin typeface="Calibri"/>
+              </a:rPr>
+              <a:t>Rapports et statistiques</a:t>
+            </a:r>
+          </a:p>
+        </p:txBody>
+      </p:sp>
+      <p:sp>
+        <p:nvSpPr>
+          <p:cNvPr id="5" name="Rectangle 4"/>
+          <p:cNvSpPr/>
+          <p:nvPr/>
+        </p:nvSpPr>
+        <p:spPr>
+          <a:xfrm>
+            <a:off x="658368" y="1481328"/>
+            <a:ext cx="1005840" cy="45720"/>
+          </a:xfrm>
+          <a:prstGeom prst="rect">
+            <a:avLst/>
+          </a:prstGeom>
+          <a:solidFill>
+            <a:srgbClr val="0071E3"/>
+          </a:solidFill>
+          <a:ln>
+            <a:noFill/>
+          </a:ln>
+          <a:effectLst/>
+        </p:spPr>
+        <p:style>
+          <a:lnRef idx="1">
+            <a:schemeClr val="accent1"/>
+          </a:lnRef>
+          <a:fillRef idx="3">
+            <a:schemeClr val="accent1"/>
+          </a:fillRef>
+          <a:effectRef idx="2">
+            <a:schemeClr val="accent1"/>
+          </a:effectRef>
+          <a:fontRef idx="minor">
+            <a:schemeClr val="lt1"/>
+          </a:fontRef>
+        </p:style>
+        <p:txBody>
+          <a:bodyPr rtlCol="0" anchor="ctr"/>
+          <a:lstStyle/>
+          <a:p>
+            <a:pPr algn="ctr"/>
+          </a:p>
+        </p:txBody>
+      </p:sp>
+      <p:pic>
+        <p:nvPicPr>
+          <p:cNvPr id="6" name="Picture 5" descr="09-rapports.png"/>
+          <p:cNvPicPr>
+            <a:picLocks noChangeAspect="1"/>
+          </p:cNvPicPr>
+          <p:nvPr/>
+        </p:nvPicPr>
+        <p:blipFill>
+          <a:blip r:embed="rId2"/>
+          <a:stretch>
+            <a:fillRect/>
+          </a:stretch>
+        </p:blipFill>
+        <p:spPr>
+          <a:xfrm>
+            <a:off x="2255367" y="1691640"/>
+            <a:ext cx="7680960" cy="4800600"/>
+          </a:xfrm>
+          <a:prstGeom prst="rect">
+            <a:avLst/>
+          </a:prstGeom>
+          <a:ln w="9525">
+            <a:solidFill>
+              <a:srgbClr val="E0E0E6"/>
+            </a:solidFill>
+          </a:ln>
+        </p:spPr>
+      </p:pic>
+      <p:sp>
+        <p:nvSpPr>
+          <p:cNvPr id="7" name="TextBox 6"/>
+          <p:cNvSpPr txBox="1"/>
+          <p:nvPr/>
+        </p:nvSpPr>
+        <p:spPr>
+          <a:xfrm>
+            <a:off x="640080" y="6355080"/>
+            <a:ext cx="10881360" cy="365760"/>
+          </a:xfrm>
+          <a:prstGeom prst="rect">
+            <a:avLst/>
+          </a:prstGeom>
+          <a:noFill/>
+        </p:spPr>
+        <p:txBody>
+          <a:bodyPr wrap="square">
+            <a:spAutoFit/>
+          </a:bodyPr>
+          <a:lstStyle/>
+          <a:p>
+            <a:pPr algn="ctr"/>
+            <a:r>
+              <a:rPr sz="1200" b="0" i="1">
+                <a:solidFill>
+                  <a:srgbClr val="6E6E73"/>
+                </a:solidFill>
+                <a:latin typeface="Calibri"/>
+              </a:rPr>
+              <a:t>Bénéfice, chiffre d'affaires et graphiques par période</a:t>
+            </a:r>
+          </a:p>
+        </p:txBody>
+      </p:sp>
+    </p:spTree>
+  </p:cSld>
+  <p:clrMapOvr>
+    <a:masterClrMapping/>
+  </p:clrMapOvr>
+</p:sld>
+</file>
+
+<file path=ppt/slides/slide23.xml><?xml version="1.0" encoding="utf-8"?>
+<p:sld xmlns:a="http://schemas.openxmlformats.org/drawingml/2006/main" xmlns:p="http://schemas.openxmlformats.org/presentationml/2006/main" xmlns:r="http://schemas.openxmlformats.org/officeDocument/2006/relationships">
+  <p:cSld>
+    <p:bg>
+      <p:bgPr>
+        <a:solidFill>
+          <a:srgbClr val="FFFFFF"/>
+        </a:solidFill>
+        <a:effectLst/>
+      </p:bgPr>
+    </p:bg>
+    <p:spTree>
+      <p:nvGrpSpPr>
+        <p:cNvPr id="1" name=""/>
+        <p:cNvGrpSpPr/>
+        <p:nvPr/>
+      </p:nvGrpSpPr>
+      <p:grpSpPr/>
+      <p:sp>
+        <p:nvSpPr>
+          <p:cNvPr id="2" name="Rectangle 1"/>
+          <p:cNvSpPr/>
+          <p:nvPr/>
+        </p:nvSpPr>
+        <p:spPr>
+          <a:xfrm>
+            <a:off x="0" y="0"/>
+            <a:ext cx="12191695" cy="164592"/>
+          </a:xfrm>
+          <a:prstGeom prst="rect">
+            <a:avLst/>
+          </a:prstGeom>
+          <a:solidFill>
+            <a:srgbClr val="0071E3"/>
+          </a:solidFill>
+          <a:ln>
+            <a:noFill/>
+          </a:ln>
+          <a:effectLst/>
+        </p:spPr>
+        <p:style>
+          <a:lnRef idx="1">
+            <a:schemeClr val="accent1"/>
+          </a:lnRef>
+          <a:fillRef idx="3">
+            <a:schemeClr val="accent1"/>
+          </a:fillRef>
+          <a:effectRef idx="2">
+            <a:schemeClr val="accent1"/>
+          </a:effectRef>
+          <a:fontRef idx="minor">
+            <a:schemeClr val="lt1"/>
+          </a:fontRef>
+        </p:style>
+        <p:txBody>
+          <a:bodyPr rtlCol="0" anchor="ctr"/>
+          <a:lstStyle/>
+          <a:p>
+            <a:pPr algn="ctr"/>
+          </a:p>
+        </p:txBody>
+      </p:sp>
+      <p:sp>
+        <p:nvSpPr>
+          <p:cNvPr id="3" name="TextBox 2"/>
+          <p:cNvSpPr txBox="1"/>
+          <p:nvPr/>
+        </p:nvSpPr>
+        <p:spPr>
+          <a:xfrm>
+            <a:off x="640080" y="502920"/>
+            <a:ext cx="10881360" cy="365760"/>
+          </a:xfrm>
+          <a:prstGeom prst="rect">
+            <a:avLst/>
+          </a:prstGeom>
+          <a:noFill/>
+        </p:spPr>
+        <p:txBody>
+          <a:bodyPr wrap="square">
+            <a:spAutoFit/>
+          </a:bodyPr>
+          <a:lstStyle/>
+          <a:p>
+            <a:r>
+              <a:rPr sz="1200" b="1" i="0">
+                <a:solidFill>
+                  <a:srgbClr val="0071E3"/>
+                </a:solidFill>
+                <a:latin typeface="Calibri"/>
+              </a:rPr>
+              <a:t>DÉMONSTRATION</a:t>
+            </a:r>
+          </a:p>
+        </p:txBody>
+      </p:sp>
+      <p:sp>
+        <p:nvSpPr>
+          <p:cNvPr id="4" name="TextBox 3"/>
+          <p:cNvSpPr txBox="1"/>
+          <p:nvPr/>
+        </p:nvSpPr>
+        <p:spPr>
+          <a:xfrm>
+            <a:off x="640080" y="777240"/>
+            <a:ext cx="10881360" cy="822960"/>
+          </a:xfrm>
+          <a:prstGeom prst="rect">
+            <a:avLst/>
+          </a:prstGeom>
+          <a:noFill/>
+        </p:spPr>
+        <p:txBody>
+          <a:bodyPr wrap="square">
+            <a:spAutoFit/>
+          </a:bodyPr>
+          <a:lstStyle/>
+          <a:p>
+            <a:r>
+              <a:rPr sz="3000" b="1" i="0">
+                <a:solidFill>
+                  <a:srgbClr val="0A2540"/>
+                </a:solidFill>
+                <a:latin typeface="Calibri"/>
+              </a:rPr>
+              <a:t>Paramètres</a:t>
+            </a:r>
+          </a:p>
+        </p:txBody>
+      </p:sp>
+      <p:sp>
+        <p:nvSpPr>
+          <p:cNvPr id="5" name="Rectangle 4"/>
+          <p:cNvSpPr/>
+          <p:nvPr/>
+        </p:nvSpPr>
+        <p:spPr>
+          <a:xfrm>
+            <a:off x="658368" y="1481328"/>
+            <a:ext cx="1005840" cy="45720"/>
+          </a:xfrm>
+          <a:prstGeom prst="rect">
+            <a:avLst/>
+          </a:prstGeom>
+          <a:solidFill>
+            <a:srgbClr val="0071E3"/>
+          </a:solidFill>
+          <a:ln>
+            <a:noFill/>
+          </a:ln>
+          <a:effectLst/>
+        </p:spPr>
+        <p:style>
+          <a:lnRef idx="1">
+            <a:schemeClr val="accent1"/>
+          </a:lnRef>
+          <a:fillRef idx="3">
+            <a:schemeClr val="accent1"/>
+          </a:fillRef>
+          <a:effectRef idx="2">
+            <a:schemeClr val="accent1"/>
+          </a:effectRef>
+          <a:fontRef idx="minor">
+            <a:schemeClr val="lt1"/>
+          </a:fontRef>
+        </p:style>
+        <p:txBody>
+          <a:bodyPr rtlCol="0" anchor="ctr"/>
+          <a:lstStyle/>
+          <a:p>
+            <a:pPr algn="ctr"/>
+          </a:p>
+        </p:txBody>
+      </p:sp>
+      <p:pic>
+        <p:nvPicPr>
+          <p:cNvPr id="6" name="Picture 5" descr="10-parametres.png"/>
+          <p:cNvPicPr>
+            <a:picLocks noChangeAspect="1"/>
+          </p:cNvPicPr>
+          <p:nvPr/>
+        </p:nvPicPr>
+        <p:blipFill>
+          <a:blip r:embed="rId2"/>
+          <a:stretch>
+            <a:fillRect/>
+          </a:stretch>
+        </p:blipFill>
+        <p:spPr>
+          <a:xfrm>
+            <a:off x="2255367" y="1691640"/>
+            <a:ext cx="7680960" cy="4800600"/>
+          </a:xfrm>
+          <a:prstGeom prst="rect">
+            <a:avLst/>
+          </a:prstGeom>
+          <a:ln w="9525">
+            <a:solidFill>
+              <a:srgbClr val="E0E0E6"/>
+            </a:solidFill>
+          </a:ln>
+        </p:spPr>
+      </p:pic>
+      <p:sp>
+        <p:nvSpPr>
+          <p:cNvPr id="7" name="TextBox 6"/>
+          <p:cNvSpPr txBox="1"/>
+          <p:nvPr/>
+        </p:nvSpPr>
+        <p:spPr>
+          <a:xfrm>
+            <a:off x="640080" y="6355080"/>
+            <a:ext cx="10881360" cy="365760"/>
+          </a:xfrm>
+          <a:prstGeom prst="rect">
+            <a:avLst/>
+          </a:prstGeom>
+          <a:noFill/>
+        </p:spPr>
+        <p:txBody>
+          <a:bodyPr wrap="square">
+            <a:spAutoFit/>
+          </a:bodyPr>
+          <a:lstStyle/>
+          <a:p>
+            <a:pPr algn="ctr"/>
+            <a:r>
+              <a:rPr sz="1200" b="0" i="1">
+                <a:solidFill>
+                  <a:srgbClr val="6E6E73"/>
+                </a:solidFill>
+                <a:latin typeface="Calibri"/>
+              </a:rPr>
+              <a:t>Référentiels : TVA, devises, unités, catégories, marques, paiements</a:t>
+            </a:r>
+          </a:p>
+        </p:txBody>
+      </p:sp>
+    </p:spTree>
+  </p:cSld>
+  <p:clrMapOvr>
+    <a:masterClrMapping/>
+  </p:clrMapOvr>
+</p:sld>
+</file>
+
+<file path=ppt/slides/slide24.xml><?xml version="1.0" encoding="utf-8"?>
+<p:sld xmlns:a="http://schemas.openxmlformats.org/drawingml/2006/main" xmlns:p="http://schemas.openxmlformats.org/presentationml/2006/main" xmlns:r="http://schemas.openxmlformats.org/officeDocument/2006/relationships">
+  <p:cSld>
+    <p:bg>
+      <p:bgPr>
+        <a:solidFill>
+          <a:srgbClr val="FFFFFF"/>
+        </a:solidFill>
+        <a:effectLst/>
+      </p:bgPr>
+    </p:bg>
+    <p:spTree>
+      <p:nvGrpSpPr>
+        <p:cNvPr id="1" name=""/>
+        <p:cNvGrpSpPr/>
+        <p:nvPr/>
+      </p:nvGrpSpPr>
+      <p:grpSpPr/>
+      <p:sp>
+        <p:nvSpPr>
+          <p:cNvPr id="2" name="Rectangle 1"/>
+          <p:cNvSpPr/>
+          <p:nvPr/>
+        </p:nvSpPr>
+        <p:spPr>
+          <a:xfrm>
+            <a:off x="0" y="0"/>
+            <a:ext cx="12191695" cy="164592"/>
+          </a:xfrm>
+          <a:prstGeom prst="rect">
+            <a:avLst/>
+          </a:prstGeom>
+          <a:solidFill>
+            <a:srgbClr val="0071E3"/>
+          </a:solidFill>
+          <a:ln>
+            <a:noFill/>
+          </a:ln>
+          <a:effectLst/>
+        </p:spPr>
+        <p:style>
+          <a:lnRef idx="1">
+            <a:schemeClr val="accent1"/>
+          </a:lnRef>
+          <a:fillRef idx="3">
+            <a:schemeClr val="accent1"/>
+          </a:fillRef>
+          <a:effectRef idx="2">
+            <a:schemeClr val="accent1"/>
+          </a:effectRef>
+          <a:fontRef idx="minor">
+            <a:schemeClr val="lt1"/>
+          </a:fontRef>
+        </p:style>
+        <p:txBody>
+          <a:bodyPr rtlCol="0" anchor="ctr"/>
+          <a:lstStyle/>
+          <a:p>
+            <a:pPr algn="ctr"/>
+          </a:p>
+        </p:txBody>
+      </p:sp>
+      <p:sp>
+        <p:nvSpPr>
+          <p:cNvPr id="3" name="TextBox 2"/>
+          <p:cNvSpPr txBox="1"/>
+          <p:nvPr/>
+        </p:nvSpPr>
+        <p:spPr>
+          <a:xfrm>
+            <a:off x="640080" y="502920"/>
+            <a:ext cx="10881360" cy="365760"/>
+          </a:xfrm>
+          <a:prstGeom prst="rect">
+            <a:avLst/>
+          </a:prstGeom>
+          <a:noFill/>
+        </p:spPr>
+        <p:txBody>
+          <a:bodyPr wrap="square">
+            <a:spAutoFit/>
+          </a:bodyPr>
+          <a:lstStyle/>
+          <a:p>
+            <a:r>
+              <a:rPr sz="1200" b="1" i="0">
+                <a:solidFill>
+                  <a:srgbClr val="0071E3"/>
+                </a:solidFill>
+                <a:latin typeface="Calibri"/>
+              </a:rPr>
+              <a:t>DÉMONSTRATION</a:t>
+            </a:r>
+          </a:p>
+        </p:txBody>
+      </p:sp>
+      <p:sp>
+        <p:nvSpPr>
+          <p:cNvPr id="4" name="TextBox 3"/>
+          <p:cNvSpPr txBox="1"/>
+          <p:nvPr/>
+        </p:nvSpPr>
+        <p:spPr>
+          <a:xfrm>
+            <a:off x="640080" y="777240"/>
+            <a:ext cx="10881360" cy="822960"/>
+          </a:xfrm>
+          <a:prstGeom prst="rect">
+            <a:avLst/>
+          </a:prstGeom>
+          <a:noFill/>
+        </p:spPr>
+        <p:txBody>
+          <a:bodyPr wrap="square">
+            <a:spAutoFit/>
+          </a:bodyPr>
+          <a:lstStyle/>
+          <a:p>
+            <a:r>
+              <a:rPr sz="3000" b="1" i="0">
+                <a:solidFill>
+                  <a:srgbClr val="0A2540"/>
+                </a:solidFill>
+                <a:latin typeface="Calibri"/>
+              </a:rPr>
+              <a:t>Place de marché client</a:t>
+            </a:r>
+          </a:p>
+        </p:txBody>
+      </p:sp>
+      <p:sp>
+        <p:nvSpPr>
+          <p:cNvPr id="5" name="Rectangle 4"/>
+          <p:cNvSpPr/>
+          <p:nvPr/>
+        </p:nvSpPr>
+        <p:spPr>
+          <a:xfrm>
+            <a:off x="658368" y="1481328"/>
+            <a:ext cx="1005840" cy="45720"/>
+          </a:xfrm>
+          <a:prstGeom prst="rect">
+            <a:avLst/>
+          </a:prstGeom>
+          <a:solidFill>
+            <a:srgbClr val="0071E3"/>
+          </a:solidFill>
+          <a:ln>
+            <a:noFill/>
+          </a:ln>
+          <a:effectLst/>
+        </p:spPr>
+        <p:style>
+          <a:lnRef idx="1">
+            <a:schemeClr val="accent1"/>
+          </a:lnRef>
+          <a:fillRef idx="3">
+            <a:schemeClr val="accent1"/>
+          </a:fillRef>
+          <a:effectRef idx="2">
+            <a:schemeClr val="accent1"/>
+          </a:effectRef>
+          <a:fontRef idx="minor">
+            <a:schemeClr val="lt1"/>
+          </a:fontRef>
+        </p:style>
+        <p:txBody>
+          <a:bodyPr rtlCol="0" anchor="ctr"/>
+          <a:lstStyle/>
+          <a:p>
+            <a:pPr algn="ctr"/>
+          </a:p>
+        </p:txBody>
+      </p:sp>
+      <p:pic>
+        <p:nvPicPr>
+          <p:cNvPr id="6" name="Picture 5" descr="11-magasin.png"/>
+          <p:cNvPicPr>
+            <a:picLocks noChangeAspect="1"/>
+          </p:cNvPicPr>
+          <p:nvPr/>
+        </p:nvPicPr>
+        <p:blipFill>
+          <a:blip r:embed="rId2"/>
+          <a:stretch>
+            <a:fillRect/>
+          </a:stretch>
+        </p:blipFill>
+        <p:spPr>
+          <a:xfrm>
+            <a:off x="2255367" y="1691640"/>
+            <a:ext cx="7680960" cy="4800600"/>
+          </a:xfrm>
+          <a:prstGeom prst="rect">
+            <a:avLst/>
+          </a:prstGeom>
+          <a:ln w="9525">
+            <a:solidFill>
+              <a:srgbClr val="E0E0E6"/>
+            </a:solidFill>
+          </a:ln>
+        </p:spPr>
+      </p:pic>
+      <p:sp>
+        <p:nvSpPr>
+          <p:cNvPr id="7" name="TextBox 6"/>
+          <p:cNvSpPr txBox="1"/>
+          <p:nvPr/>
+        </p:nvSpPr>
+        <p:spPr>
+          <a:xfrm>
+            <a:off x="640080" y="6355080"/>
+            <a:ext cx="10881360" cy="365760"/>
+          </a:xfrm>
+          <a:prstGeom prst="rect">
+            <a:avLst/>
+          </a:prstGeom>
+          <a:noFill/>
+        </p:spPr>
+        <p:txBody>
+          <a:bodyPr wrap="square">
+            <a:spAutoFit/>
+          </a:bodyPr>
+          <a:lstStyle/>
+          <a:p>
+            <a:pPr algn="ctr"/>
+            <a:r>
+              <a:rPr sz="1200" b="0" i="1">
+                <a:solidFill>
+                  <a:srgbClr val="6E6E73"/>
+                </a:solidFill>
+                <a:latin typeface="Calibri"/>
+              </a:rPr>
+              <a:t>Catalogue multi-boutiques : recherche, filtre boutique et panier</a:t>
+            </a:r>
+          </a:p>
+        </p:txBody>
+      </p:sp>
+    </p:spTree>
+  </p:cSld>
+  <p:clrMapOvr>
+    <a:masterClrMapping/>
+  </p:clrMapOvr>
+</p:sld>
+</file>
+
+<file path=ppt/slides/slide25.xml><?xml version="1.0" encoding="utf-8"?>
+<p:sld xmlns:a="http://schemas.openxmlformats.org/drawingml/2006/main" xmlns:p="http://schemas.openxmlformats.org/presentationml/2006/main" xmlns:r="http://schemas.openxmlformats.org/officeDocument/2006/relationships">
+  <p:cSld>
+    <p:bg>
+      <p:bgPr>
+        <a:solidFill>
+          <a:srgbClr val="FFFFFF"/>
+        </a:solidFill>
+        <a:effectLst/>
+      </p:bgPr>
+    </p:bg>
+    <p:spTree>
+      <p:nvGrpSpPr>
+        <p:cNvPr id="1" name=""/>
+        <p:cNvGrpSpPr/>
+        <p:nvPr/>
+      </p:nvGrpSpPr>
+      <p:grpSpPr/>
+      <p:sp>
+        <p:nvSpPr>
+          <p:cNvPr id="2" name="Rectangle 1"/>
+          <p:cNvSpPr/>
+          <p:nvPr/>
+        </p:nvSpPr>
+        <p:spPr>
+          <a:xfrm>
+            <a:off x="0" y="0"/>
+            <a:ext cx="12191695" cy="164592"/>
+          </a:xfrm>
+          <a:prstGeom prst="rect">
+            <a:avLst/>
+          </a:prstGeom>
+          <a:solidFill>
+            <a:srgbClr val="0071E3"/>
+          </a:solidFill>
+          <a:ln>
+            <a:noFill/>
+          </a:ln>
+          <a:effectLst/>
+        </p:spPr>
+        <p:style>
+          <a:lnRef idx="1">
+            <a:schemeClr val="accent1"/>
+          </a:lnRef>
+          <a:fillRef idx="3">
+            <a:schemeClr val="accent1"/>
+          </a:fillRef>
+          <a:effectRef idx="2">
+            <a:schemeClr val="accent1"/>
+          </a:effectRef>
+          <a:fontRef idx="minor">
+            <a:schemeClr val="lt1"/>
+          </a:fontRef>
+        </p:style>
+        <p:txBody>
+          <a:bodyPr rtlCol="0" anchor="ctr"/>
+          <a:lstStyle/>
+          <a:p>
+            <a:pPr algn="ctr"/>
+          </a:p>
+        </p:txBody>
+      </p:sp>
+      <p:sp>
+        <p:nvSpPr>
+          <p:cNvPr id="3" name="TextBox 2"/>
+          <p:cNvSpPr txBox="1"/>
+          <p:nvPr/>
+        </p:nvSpPr>
+        <p:spPr>
+          <a:xfrm>
+            <a:off x="640080" y="502920"/>
+            <a:ext cx="10881360" cy="365760"/>
+          </a:xfrm>
+          <a:prstGeom prst="rect">
+            <a:avLst/>
+          </a:prstGeom>
+          <a:noFill/>
+        </p:spPr>
+        <p:txBody>
+          <a:bodyPr wrap="square">
+            <a:spAutoFit/>
+          </a:bodyPr>
+          <a:lstStyle/>
+          <a:p>
+            <a:r>
+              <a:rPr sz="1200" b="1" i="0">
+                <a:solidFill>
+                  <a:srgbClr val="0071E3"/>
+                </a:solidFill>
+                <a:latin typeface="Calibri"/>
+              </a:rPr>
+              <a:t>DÉMONSTRATION</a:t>
+            </a:r>
+          </a:p>
+        </p:txBody>
+      </p:sp>
+      <p:sp>
+        <p:nvSpPr>
+          <p:cNvPr id="4" name="TextBox 3"/>
+          <p:cNvSpPr txBox="1"/>
+          <p:nvPr/>
+        </p:nvSpPr>
+        <p:spPr>
+          <a:xfrm>
+            <a:off x="640080" y="777240"/>
+            <a:ext cx="10881360" cy="822960"/>
+          </a:xfrm>
+          <a:prstGeom prst="rect">
+            <a:avLst/>
+          </a:prstGeom>
+          <a:noFill/>
+        </p:spPr>
+        <p:txBody>
+          <a:bodyPr wrap="square">
+            <a:spAutoFit/>
+          </a:bodyPr>
+          <a:lstStyle/>
+          <a:p>
+            <a:r>
+              <a:rPr sz="3000" b="1" i="0">
+                <a:solidFill>
+                  <a:srgbClr val="0A2540"/>
+                </a:solidFill>
+                <a:latin typeface="Calibri"/>
+              </a:rPr>
+              <a:t>Espace client — Mes locations</a:t>
+            </a:r>
+          </a:p>
+        </p:txBody>
+      </p:sp>
+      <p:sp>
+        <p:nvSpPr>
+          <p:cNvPr id="5" name="Rectangle 4"/>
+          <p:cNvSpPr/>
+          <p:nvPr/>
+        </p:nvSpPr>
+        <p:spPr>
+          <a:xfrm>
+            <a:off x="658368" y="1481328"/>
+            <a:ext cx="1005840" cy="45720"/>
+          </a:xfrm>
+          <a:prstGeom prst="rect">
+            <a:avLst/>
+          </a:prstGeom>
+          <a:solidFill>
+            <a:srgbClr val="0071E3"/>
+          </a:solidFill>
+          <a:ln>
+            <a:noFill/>
+          </a:ln>
+          <a:effectLst/>
+        </p:spPr>
+        <p:style>
+          <a:lnRef idx="1">
+            <a:schemeClr val="accent1"/>
+          </a:lnRef>
+          <a:fillRef idx="3">
+            <a:schemeClr val="accent1"/>
+          </a:fillRef>
+          <a:effectRef idx="2">
+            <a:schemeClr val="accent1"/>
+          </a:effectRef>
+          <a:fontRef idx="minor">
+            <a:schemeClr val="lt1"/>
+          </a:fontRef>
+        </p:style>
+        <p:txBody>
+          <a:bodyPr rtlCol="0" anchor="ctr"/>
+          <a:lstStyle/>
+          <a:p>
+            <a:pPr algn="ctr"/>
+          </a:p>
+        </p:txBody>
+      </p:sp>
+      <p:pic>
+        <p:nvPicPr>
+          <p:cNvPr id="6" name="Picture 5" descr="12-mes-locations.png"/>
+          <p:cNvPicPr>
+            <a:picLocks noChangeAspect="1"/>
+          </p:cNvPicPr>
+          <p:nvPr/>
+        </p:nvPicPr>
+        <p:blipFill>
+          <a:blip r:embed="rId2"/>
+          <a:stretch>
+            <a:fillRect/>
+          </a:stretch>
+        </p:blipFill>
+        <p:spPr>
+          <a:xfrm>
+            <a:off x="2255367" y="1691640"/>
+            <a:ext cx="7680960" cy="4800600"/>
+          </a:xfrm>
+          <a:prstGeom prst="rect">
+            <a:avLst/>
+          </a:prstGeom>
+          <a:ln w="9525">
+            <a:solidFill>
+              <a:srgbClr val="E0E0E6"/>
+            </a:solidFill>
+          </a:ln>
+        </p:spPr>
+      </p:pic>
+      <p:sp>
+        <p:nvSpPr>
+          <p:cNvPr id="7" name="TextBox 6"/>
+          <p:cNvSpPr txBox="1"/>
+          <p:nvPr/>
+        </p:nvSpPr>
+        <p:spPr>
+          <a:xfrm>
+            <a:off x="640080" y="6355080"/>
+            <a:ext cx="10881360" cy="365760"/>
+          </a:xfrm>
+          <a:prstGeom prst="rect">
+            <a:avLst/>
+          </a:prstGeom>
+          <a:noFill/>
+        </p:spPr>
+        <p:txBody>
+          <a:bodyPr wrap="square">
+            <a:spAutoFit/>
+          </a:bodyPr>
+          <a:lstStyle/>
+          <a:p>
+            <a:pPr algn="ctr"/>
+            <a:r>
+              <a:rPr sz="1200" b="0" i="1">
+                <a:solidFill>
+                  <a:srgbClr val="6E6E73"/>
+                </a:solidFill>
+                <a:latin typeface="Calibri"/>
+              </a:rPr>
+              <a:t>Suivi des locations et téléchargement des factures</a:t>
+            </a:r>
+          </a:p>
+        </p:txBody>
+      </p:sp>
+    </p:spTree>
+  </p:cSld>
+  <p:clrMapOvr>
+    <a:masterClrMapping/>
+  </p:clrMapOvr>
+</p:sld>
+</file>
+
+<file path=ppt/slides/slide26.xml><?xml version="1.0" encoding="utf-8"?>
+<p:sld xmlns:a="http://schemas.openxmlformats.org/drawingml/2006/main" xmlns:p="http://schemas.openxmlformats.org/presentationml/2006/main" xmlns:r="http://schemas.openxmlformats.org/officeDocument/2006/relationships">
+  <p:cSld>
+    <p:bg>
+      <p:bgPr>
+        <a:solidFill>
+          <a:srgbClr val="FFFFFF"/>
+        </a:solidFill>
+        <a:effectLst/>
+      </p:bgPr>
+    </p:bg>
+    <p:spTree>
+      <p:nvGrpSpPr>
+        <p:cNvPr id="1" name=""/>
+        <p:cNvGrpSpPr/>
+        <p:nvPr/>
+      </p:nvGrpSpPr>
+      <p:grpSpPr/>
+      <p:sp>
+        <p:nvSpPr>
+          <p:cNvPr id="2" name="Rectangle 1"/>
+          <p:cNvSpPr/>
+          <p:nvPr/>
+        </p:nvSpPr>
+        <p:spPr>
+          <a:xfrm>
+            <a:off x="0" y="0"/>
+            <a:ext cx="12191695" cy="164592"/>
+          </a:xfrm>
+          <a:prstGeom prst="rect">
+            <a:avLst/>
+          </a:prstGeom>
+          <a:solidFill>
+            <a:srgbClr val="0071E3"/>
+          </a:solidFill>
+          <a:ln>
+            <a:noFill/>
+          </a:ln>
+          <a:effectLst/>
+        </p:spPr>
+        <p:style>
+          <a:lnRef idx="1">
+            <a:schemeClr val="accent1"/>
+          </a:lnRef>
+          <a:fillRef idx="3">
+            <a:schemeClr val="accent1"/>
+          </a:fillRef>
+          <a:effectRef idx="2">
+            <a:schemeClr val="accent1"/>
+          </a:effectRef>
+          <a:fontRef idx="minor">
+            <a:schemeClr val="lt1"/>
+          </a:fontRef>
+        </p:style>
+        <p:txBody>
+          <a:bodyPr rtlCol="0" anchor="ctr"/>
+          <a:lstStyle/>
+          <a:p>
+            <a:pPr algn="ctr"/>
+          </a:p>
+        </p:txBody>
+      </p:sp>
+      <p:sp>
+        <p:nvSpPr>
+          <p:cNvPr id="3" name="TextBox 2"/>
+          <p:cNvSpPr txBox="1"/>
+          <p:nvPr/>
+        </p:nvSpPr>
+        <p:spPr>
+          <a:xfrm>
+            <a:off x="640080" y="502920"/>
+            <a:ext cx="10881360" cy="365760"/>
+          </a:xfrm>
+          <a:prstGeom prst="rect">
+            <a:avLst/>
+          </a:prstGeom>
+          <a:noFill/>
+        </p:spPr>
+        <p:txBody>
+          <a:bodyPr wrap="square">
+            <a:spAutoFit/>
+          </a:bodyPr>
+          <a:lstStyle/>
+          <a:p>
+            <a:r>
+              <a:rPr sz="1200" b="1" i="0">
+                <a:solidFill>
+                  <a:srgbClr val="0071E3"/>
+                </a:solidFill>
+                <a:latin typeface="Calibri"/>
+              </a:rPr>
+              <a:t>MISE EN ŒUVRE</a:t>
+            </a:r>
+          </a:p>
+        </p:txBody>
+      </p:sp>
+      <p:sp>
+        <p:nvSpPr>
+          <p:cNvPr id="4" name="TextBox 3"/>
+          <p:cNvSpPr txBox="1"/>
+          <p:nvPr/>
+        </p:nvSpPr>
+        <p:spPr>
+          <a:xfrm>
+            <a:off x="640080" y="777240"/>
+            <a:ext cx="10881360" cy="822960"/>
+          </a:xfrm>
+          <a:prstGeom prst="rect">
+            <a:avLst/>
+          </a:prstGeom>
+          <a:noFill/>
+        </p:spPr>
+        <p:txBody>
+          <a:bodyPr wrap="square">
+            <a:spAutoFit/>
+          </a:bodyPr>
+          <a:lstStyle/>
+          <a:p>
+            <a:r>
+              <a:rPr sz="3000" b="1" i="0">
+                <a:solidFill>
+                  <a:srgbClr val="0A2540"/>
+                </a:solidFill>
+                <a:latin typeface="Calibri"/>
+              </a:rPr>
+              <a:t>Déploiement et démonstration</a:t>
+            </a:r>
+          </a:p>
+        </p:txBody>
+      </p:sp>
+      <p:sp>
+        <p:nvSpPr>
+          <p:cNvPr id="5" name="Rectangle 4"/>
+          <p:cNvSpPr/>
+          <p:nvPr/>
+        </p:nvSpPr>
+        <p:spPr>
+          <a:xfrm>
+            <a:off x="658368" y="1481328"/>
+            <a:ext cx="1005840" cy="45720"/>
+          </a:xfrm>
+          <a:prstGeom prst="rect">
+            <a:avLst/>
+          </a:prstGeom>
+          <a:solidFill>
+            <a:srgbClr val="0071E3"/>
+          </a:solidFill>
+          <a:ln>
+            <a:noFill/>
+          </a:ln>
+          <a:effectLst/>
+        </p:spPr>
+        <p:style>
+          <a:lnRef idx="1">
+            <a:schemeClr val="accent1"/>
+          </a:lnRef>
+          <a:fillRef idx="3">
+            <a:schemeClr val="accent1"/>
+          </a:fillRef>
+          <a:effectRef idx="2">
+            <a:schemeClr val="accent1"/>
+          </a:effectRef>
+          <a:fontRef idx="minor">
+            <a:schemeClr val="lt1"/>
+          </a:fontRef>
+        </p:style>
+        <p:txBody>
+          <a:bodyPr rtlCol="0" anchor="ctr"/>
+          <a:lstStyle/>
+          <a:p>
+            <a:pPr algn="ctr"/>
+          </a:p>
+        </p:txBody>
+      </p:sp>
+      <p:sp>
+        <p:nvSpPr>
+          <p:cNvPr id="6" name="TextBox 5"/>
+          <p:cNvSpPr txBox="1"/>
+          <p:nvPr/>
+        </p:nvSpPr>
+        <p:spPr>
+          <a:xfrm>
+            <a:off x="731520" y="1828800"/>
+            <a:ext cx="10698480" cy="4572000"/>
+          </a:xfrm>
+          <a:prstGeom prst="rect">
+            <a:avLst/>
+          </a:prstGeom>
+          <a:noFill/>
+        </p:spPr>
+        <p:txBody>
+          <a:bodyPr wrap="square">
+            <a:spAutoFit/>
+          </a:bodyPr>
+          <a:lstStyle/>
+          <a:p>
+            <a:pPr>
+              <a:spcBef>
+                <a:spcPts val="200"/>
+              </a:spcBef>
+              <a:spcAft>
+                <a:spcPts val="800"/>
+              </a:spcAft>
+            </a:pPr>
+            <a:r>
+              <a:rPr sz="2000" b="1" i="0">
+                <a:solidFill>
+                  <a:srgbClr val="0071E3"/>
+                </a:solidFill>
+                <a:latin typeface="Calibri"/>
+              </a:rPr>
+              <a:t>▸ </a:t>
+            </a:r>
+            <a:r>
+              <a:rPr sz="2000" b="0" i="0">
+                <a:solidFill>
+                  <a:srgbClr val="1D1D1F"/>
+                </a:solidFill>
+                <a:latin typeface="Calibri"/>
+              </a:rPr>
+              <a:t>Installation Windows « en un clic » (script automatisé : dépendances, base, données de démo).</a:t>
+            </a:r>
+          </a:p>
+          <a:p>
+            <a:pPr>
+              <a:spcBef>
+                <a:spcPts val="200"/>
+              </a:spcBef>
+              <a:spcAft>
+                <a:spcPts val="800"/>
+              </a:spcAft>
+            </a:pPr>
+            <a:r>
+              <a:rPr sz="2000" b="1" i="0">
+                <a:solidFill>
+                  <a:srgbClr val="0071E3"/>
+                </a:solidFill>
+                <a:latin typeface="Calibri"/>
+              </a:rPr>
+              <a:t>▸ </a:t>
+            </a:r>
+            <a:r>
+              <a:rPr sz="2000" b="1" i="0">
+                <a:solidFill>
+                  <a:srgbClr val="0A2540"/>
+                </a:solidFill>
+                <a:latin typeface="Calibri"/>
+              </a:rPr>
+              <a:t>Backend : http://127.0.0.1:8000</a:t>
+            </a:r>
+            <a:r>
+              <a:rPr sz="2000" b="0" i="0">
+                <a:solidFill>
+                  <a:srgbClr val="1D1D1F"/>
+                </a:solidFill>
+                <a:latin typeface="Calibri"/>
+              </a:rPr>
+              <a:t> — Frontend : http://localhost:5173</a:t>
+            </a:r>
+          </a:p>
+          <a:p>
+            <a:pPr>
+              <a:spcBef>
+                <a:spcPts val="200"/>
+              </a:spcBef>
+              <a:spcAft>
+                <a:spcPts val="800"/>
+              </a:spcAft>
+            </a:pPr>
+            <a:r>
+              <a:rPr sz="2000" b="1" i="0">
+                <a:solidFill>
+                  <a:srgbClr val="0071E3"/>
+                </a:solidFill>
+                <a:latin typeface="Calibri"/>
+              </a:rPr>
+              <a:t>▸ </a:t>
+            </a:r>
+            <a:r>
+              <a:rPr sz="2000" b="0" i="0">
+                <a:solidFill>
+                  <a:srgbClr val="1D1D1F"/>
+                </a:solidFill>
+                <a:latin typeface="Calibri"/>
+              </a:rPr>
+              <a:t>Boutiques de démonstration prêtes à l'emploi (Makita, Transpalette, EventPro).</a:t>
+            </a:r>
+          </a:p>
+          <a:p>
+            <a:pPr>
+              <a:spcBef>
+                <a:spcPts val="200"/>
+              </a:spcBef>
+              <a:spcAft>
+                <a:spcPts val="800"/>
+              </a:spcAft>
+            </a:pPr>
+            <a:r>
+              <a:rPr sz="2000" b="1" i="0">
+                <a:solidFill>
+                  <a:srgbClr val="0071E3"/>
+                </a:solidFill>
+                <a:latin typeface="Calibri"/>
+              </a:rPr>
+              <a:t>▸ </a:t>
+            </a:r>
+            <a:r>
+              <a:rPr sz="2000" b="0" i="0">
+                <a:solidFill>
+                  <a:srgbClr val="1D1D1F"/>
+                </a:solidFill>
+                <a:latin typeface="Calibri"/>
+              </a:rPr>
+              <a:t>Code source versionné sur GitHub.</a:t>
+            </a:r>
+          </a:p>
+          <a:p>
+            <a:pPr>
+              <a:spcBef>
+                <a:spcPts val="200"/>
+              </a:spcBef>
+              <a:spcAft>
+                <a:spcPts val="800"/>
+              </a:spcAft>
+            </a:pPr>
+            <a:r>
+              <a:rPr sz="2000" b="1" i="0">
+                <a:solidFill>
+                  <a:srgbClr val="0071E3"/>
+                </a:solidFill>
+                <a:latin typeface="Calibri"/>
+              </a:rPr>
+              <a:t>▸ </a:t>
+            </a:r>
+            <a:r>
+              <a:rPr sz="2000" b="0" i="0">
+                <a:solidFill>
+                  <a:srgbClr val="1D1D1F"/>
+                </a:solidFill>
+                <a:latin typeface="Calibri"/>
+              </a:rPr>
+              <a:t>Démonstration en direct : connexion, catalogue, panier, location, facture PDF, rapports.</a:t>
+            </a:r>
+          </a:p>
+        </p:txBody>
+      </p:sp>
+    </p:spTree>
+  </p:cSld>
+  <p:clrMapOvr>
+    <a:masterClrMapping/>
+  </p:clrMapOvr>
+</p:sld>
+</file>
+
+<file path=ppt/slides/slide27.xml><?xml version="1.0" encoding="utf-8"?>
+<p:sld xmlns:a="http://schemas.openxmlformats.org/drawingml/2006/main" xmlns:p="http://schemas.openxmlformats.org/presentationml/2006/main" xmlns:r="http://schemas.openxmlformats.org/officeDocument/2006/relationships">
+  <p:cSld>
+    <p:bg>
+      <p:bgPr>
+        <a:solidFill>
+          <a:srgbClr val="FFFFFF"/>
+        </a:solidFill>
+        <a:effectLst/>
+      </p:bgPr>
+    </p:bg>
+    <p:spTree>
+      <p:nvGrpSpPr>
+        <p:cNvPr id="1" name=""/>
+        <p:cNvGrpSpPr/>
+        <p:nvPr/>
+      </p:nvGrpSpPr>
+      <p:grpSpPr/>
+      <p:sp>
+        <p:nvSpPr>
+          <p:cNvPr id="2" name="Rectangle 1"/>
+          <p:cNvSpPr/>
+          <p:nvPr/>
+        </p:nvSpPr>
+        <p:spPr>
+          <a:xfrm>
+            <a:off x="0" y="0"/>
+            <a:ext cx="12191695" cy="164592"/>
+          </a:xfrm>
+          <a:prstGeom prst="rect">
+            <a:avLst/>
+          </a:prstGeom>
+          <a:solidFill>
+            <a:srgbClr val="0071E3"/>
+          </a:solidFill>
+          <a:ln>
+            <a:noFill/>
+          </a:ln>
+          <a:effectLst/>
+        </p:spPr>
+        <p:style>
+          <a:lnRef idx="1">
+            <a:schemeClr val="accent1"/>
+          </a:lnRef>
+          <a:fillRef idx="3">
+            <a:schemeClr val="accent1"/>
+          </a:fillRef>
+          <a:effectRef idx="2">
+            <a:schemeClr val="accent1"/>
+          </a:effectRef>
+          <a:fontRef idx="minor">
+            <a:schemeClr val="lt1"/>
+          </a:fontRef>
+        </p:style>
+        <p:txBody>
+          <a:bodyPr rtlCol="0" anchor="ctr"/>
+          <a:lstStyle/>
+          <a:p>
+            <a:pPr algn="ctr"/>
+          </a:p>
+        </p:txBody>
+      </p:sp>
+      <p:sp>
+        <p:nvSpPr>
+          <p:cNvPr id="3" name="TextBox 2"/>
+          <p:cNvSpPr txBox="1"/>
+          <p:nvPr/>
+        </p:nvSpPr>
+        <p:spPr>
+          <a:xfrm>
+            <a:off x="640080" y="502920"/>
+            <a:ext cx="10881360" cy="365760"/>
+          </a:xfrm>
+          <a:prstGeom prst="rect">
+            <a:avLst/>
+          </a:prstGeom>
+          <a:noFill/>
+        </p:spPr>
+        <p:txBody>
+          <a:bodyPr wrap="square">
+            <a:spAutoFit/>
+          </a:bodyPr>
+          <a:lstStyle/>
+          <a:p>
+            <a:r>
+              <a:rPr sz="1200" b="1" i="0">
+                <a:solidFill>
+                  <a:srgbClr val="0071E3"/>
+                </a:solidFill>
+                <a:latin typeface="Calibri"/>
+              </a:rPr>
+              <a:t>CONCLUSION</a:t>
+            </a:r>
+          </a:p>
+        </p:txBody>
+      </p:sp>
+      <p:sp>
+        <p:nvSpPr>
+          <p:cNvPr id="4" name="TextBox 3"/>
+          <p:cNvSpPr txBox="1"/>
+          <p:nvPr/>
+        </p:nvSpPr>
+        <p:spPr>
+          <a:xfrm>
+            <a:off x="640080" y="777240"/>
+            <a:ext cx="10881360" cy="822960"/>
+          </a:xfrm>
+          <a:prstGeom prst="rect">
+            <a:avLst/>
+          </a:prstGeom>
+          <a:noFill/>
+        </p:spPr>
+        <p:txBody>
+          <a:bodyPr wrap="square">
+            <a:spAutoFit/>
+          </a:bodyPr>
+          <a:lstStyle/>
+          <a:p>
+            <a:r>
+              <a:rPr sz="3000" b="1" i="0">
+                <a:solidFill>
+                  <a:srgbClr val="0A2540"/>
+                </a:solidFill>
+                <a:latin typeface="Calibri"/>
+              </a:rPr>
+              <a:t>Conclusion et perspectives</a:t>
+            </a:r>
+          </a:p>
+        </p:txBody>
+      </p:sp>
+      <p:sp>
+        <p:nvSpPr>
+          <p:cNvPr id="5" name="Rectangle 4"/>
+          <p:cNvSpPr/>
+          <p:nvPr/>
+        </p:nvSpPr>
+        <p:spPr>
+          <a:xfrm>
+            <a:off x="658368" y="1481328"/>
+            <a:ext cx="1005840" cy="45720"/>
+          </a:xfrm>
+          <a:prstGeom prst="rect">
+            <a:avLst/>
+          </a:prstGeom>
+          <a:solidFill>
+            <a:srgbClr val="0071E3"/>
+          </a:solidFill>
+          <a:ln>
+            <a:noFill/>
+          </a:ln>
+          <a:effectLst/>
+        </p:spPr>
+        <p:style>
+          <a:lnRef idx="1">
+            <a:schemeClr val="accent1"/>
+          </a:lnRef>
+          <a:fillRef idx="3">
+            <a:schemeClr val="accent1"/>
+          </a:fillRef>
+          <a:effectRef idx="2">
+            <a:schemeClr val="accent1"/>
+          </a:effectRef>
+          <a:fontRef idx="minor">
+            <a:schemeClr val="lt1"/>
+          </a:fontRef>
+        </p:style>
+        <p:txBody>
+          <a:bodyPr rtlCol="0" anchor="ctr"/>
+          <a:lstStyle/>
+          <a:p>
+            <a:pPr algn="ctr"/>
+          </a:p>
+        </p:txBody>
+      </p:sp>
+      <p:sp>
+        <p:nvSpPr>
+          <p:cNvPr id="6" name="TextBox 5"/>
+          <p:cNvSpPr txBox="1"/>
+          <p:nvPr/>
+        </p:nvSpPr>
+        <p:spPr>
+          <a:xfrm>
+            <a:off x="731520" y="1828800"/>
+            <a:ext cx="10698480" cy="4572000"/>
+          </a:xfrm>
+          <a:prstGeom prst="rect">
+            <a:avLst/>
+          </a:prstGeom>
+          <a:noFill/>
+        </p:spPr>
+        <p:txBody>
+          <a:bodyPr wrap="square">
+            <a:spAutoFit/>
+          </a:bodyPr>
+          <a:lstStyle/>
+          <a:p>
+            <a:pPr>
+              <a:spcBef>
+                <a:spcPts val="200"/>
+              </a:spcBef>
+              <a:spcAft>
+                <a:spcPts val="800"/>
+              </a:spcAft>
+            </a:pPr>
+            <a:r>
+              <a:rPr sz="2000" b="1" i="0">
+                <a:solidFill>
+                  <a:srgbClr val="0071E3"/>
+                </a:solidFill>
+                <a:latin typeface="Calibri"/>
+              </a:rPr>
+              <a:t>▸ </a:t>
+            </a:r>
+            <a:r>
+              <a:rPr sz="2000" b="0" i="0">
+                <a:solidFill>
+                  <a:srgbClr val="1D1D1F"/>
+                </a:solidFill>
+                <a:latin typeface="Calibri"/>
+              </a:rPr>
+              <a:t>Tous les objectifs ont été atteints : cycle complet de location, encaissements, PDF, multi-boutiques.</a:t>
+            </a:r>
+          </a:p>
+          <a:p>
+            <a:pPr>
+              <a:spcBef>
+                <a:spcPts val="200"/>
+              </a:spcBef>
+              <a:spcAft>
+                <a:spcPts val="800"/>
+              </a:spcAft>
+            </a:pPr>
+            <a:r>
+              <a:rPr sz="2000" b="1" i="0">
+                <a:solidFill>
+                  <a:srgbClr val="0071E3"/>
+                </a:solidFill>
+                <a:latin typeface="Calibri"/>
+              </a:rPr>
+              <a:t>▸ </a:t>
+            </a:r>
+            <a:r>
+              <a:rPr sz="2000" b="0" i="0">
+                <a:solidFill>
+                  <a:srgbClr val="1D1D1F"/>
+                </a:solidFill>
+                <a:latin typeface="Calibri"/>
+              </a:rPr>
+              <a:t>Maîtrise du développement full-stack (Laravel + React) et de la conception (MVC, base de données).</a:t>
+            </a:r>
+          </a:p>
+          <a:p>
+            <a:pPr lvl="1">
+              <a:spcBef>
+                <a:spcPts val="200"/>
+              </a:spcBef>
+              <a:spcAft>
+                <a:spcPts val="800"/>
+              </a:spcAft>
+            </a:pPr>
+            <a:r>
+              <a:rPr sz="2000" b="0" i="0">
+                <a:solidFill>
+                  <a:srgbClr val="6E6E73"/>
+                </a:solidFill>
+                <a:latin typeface="Calibri"/>
+              </a:rPr>
+              <a:t>•  </a:t>
+            </a:r>
+            <a:r>
+              <a:rPr sz="1800" b="0" i="0">
+                <a:solidFill>
+                  <a:srgbClr val="1D1D1F"/>
+                </a:solidFill>
+                <a:latin typeface="Calibri"/>
+              </a:rPr>
+              <a:t>Perspectives :</a:t>
+            </a:r>
+          </a:p>
+          <a:p>
+            <a:pPr lvl="1">
+              <a:spcBef>
+                <a:spcPts val="200"/>
+              </a:spcBef>
+              <a:spcAft>
+                <a:spcPts val="800"/>
+              </a:spcAft>
+            </a:pPr>
+            <a:r>
+              <a:rPr sz="2000" b="0" i="0">
+                <a:solidFill>
+                  <a:srgbClr val="6E6E73"/>
+                </a:solidFill>
+                <a:latin typeface="Calibri"/>
+              </a:rPr>
+              <a:t>•  </a:t>
+            </a:r>
+            <a:r>
+              <a:rPr sz="1800" b="0" i="0">
+                <a:solidFill>
+                  <a:srgbClr val="1D1D1F"/>
+                </a:solidFill>
+                <a:latin typeface="Calibri"/>
+              </a:rPr>
+              <a:t>Paiement en ligne (CMI / Stripe).</a:t>
+            </a:r>
+          </a:p>
+          <a:p>
+            <a:pPr lvl="1">
+              <a:spcBef>
+                <a:spcPts val="200"/>
+              </a:spcBef>
+              <a:spcAft>
+                <a:spcPts val="800"/>
+              </a:spcAft>
+            </a:pPr>
+            <a:r>
+              <a:rPr sz="2000" b="0" i="0">
+                <a:solidFill>
+                  <a:srgbClr val="6E6E73"/>
+                </a:solidFill>
+                <a:latin typeface="Calibri"/>
+              </a:rPr>
+              <a:t>•  </a:t>
+            </a:r>
+            <a:r>
+              <a:rPr sz="1800" b="0" i="0">
+                <a:solidFill>
+                  <a:srgbClr val="1D1D1F"/>
+                </a:solidFill>
+                <a:latin typeface="Calibri"/>
+              </a:rPr>
+              <a:t>Notifications automatiques (rappels de retour).</a:t>
+            </a:r>
+          </a:p>
+          <a:p>
+            <a:pPr lvl="1">
+              <a:spcBef>
+                <a:spcPts val="200"/>
+              </a:spcBef>
+              <a:spcAft>
+                <a:spcPts val="800"/>
+              </a:spcAft>
+            </a:pPr>
+            <a:r>
+              <a:rPr sz="2000" b="0" i="0">
+                <a:solidFill>
+                  <a:srgbClr val="6E6E73"/>
+                </a:solidFill>
+                <a:latin typeface="Calibri"/>
+              </a:rPr>
+              <a:t>•  </a:t>
+            </a:r>
+            <a:r>
+              <a:rPr sz="1800" b="0" i="0">
+                <a:solidFill>
+                  <a:srgbClr val="1D1D1F"/>
+                </a:solidFill>
+                <a:latin typeface="Calibri"/>
+              </a:rPr>
+              <a:t>Application mobile native.</a:t>
+            </a:r>
+          </a:p>
+          <a:p>
+            <a:pPr lvl="1">
+              <a:spcBef>
+                <a:spcPts val="200"/>
+              </a:spcBef>
+              <a:spcAft>
+                <a:spcPts val="800"/>
+              </a:spcAft>
+            </a:pPr>
+            <a:r>
+              <a:rPr sz="2000" b="0" i="0">
+                <a:solidFill>
+                  <a:srgbClr val="6E6E73"/>
+                </a:solidFill>
+                <a:latin typeface="Calibri"/>
+              </a:rPr>
+              <a:t>•  </a:t>
+            </a:r>
+            <a:r>
+              <a:rPr sz="1800" b="0" i="0">
+                <a:solidFill>
+                  <a:srgbClr val="1D1D1F"/>
+                </a:solidFill>
+                <a:latin typeface="Calibri"/>
+              </a:rPr>
+              <a:t>Export des rapports (PDF / Excel).</a:t>
+            </a:r>
+          </a:p>
+        </p:txBody>
+      </p:sp>
+    </p:spTree>
+  </p:cSld>
+  <p:clrMapOvr>
+    <a:masterClrMapping/>
+  </p:clrMapOvr>
+</p:sld>
+</file>
+
+<file path=ppt/slides/slide28.xml><?xml version="1.0" encoding="utf-8"?>
+<p:sld xmlns:a="http://schemas.openxmlformats.org/drawingml/2006/main" xmlns:p="http://schemas.openxmlformats.org/presentationml/2006/main" xmlns:r="http://schemas.openxmlformats.org/officeDocument/2006/relationships">
+  <p:cSld>
+    <p:bg>
+      <p:bgPr>
+        <a:solidFill>
+          <a:srgbClr val="0A2540"/>
+        </a:solidFill>
+        <a:effectLst/>
+      </p:bgPr>
+    </p:bg>
+    <p:spTree>
+      <p:nvGrpSpPr>
+        <p:cNvPr id="1" name=""/>
+        <p:cNvGrpSpPr/>
+        <p:nvPr/>
+      </p:nvGrpSpPr>
+      <p:grpSpPr/>
+      <p:sp>
+        <p:nvSpPr>
+          <p:cNvPr id="2" name="Rectangle 1"/>
+          <p:cNvSpPr/>
+          <p:nvPr/>
+        </p:nvSpPr>
+        <p:spPr>
+          <a:xfrm>
+            <a:off x="0" y="0"/>
+            <a:ext cx="12191695" cy="201168"/>
+          </a:xfrm>
+          <a:prstGeom prst="rect">
+            <a:avLst/>
+          </a:prstGeom>
+          <a:solidFill>
+            <a:srgbClr val="0071E3"/>
+          </a:solidFill>
+          <a:ln>
+            <a:noFill/>
+          </a:ln>
+          <a:effectLst/>
+        </p:spPr>
+        <p:style>
+          <a:lnRef idx="1">
+            <a:schemeClr val="accent1"/>
+          </a:lnRef>
+          <a:fillRef idx="3">
+            <a:schemeClr val="accent1"/>
+          </a:fillRef>
+          <a:effectRef idx="2">
+            <a:schemeClr val="accent1"/>
+          </a:effectRef>
+          <a:fontRef idx="minor">
+            <a:schemeClr val="lt1"/>
+          </a:fontRef>
+        </p:style>
+        <p:txBody>
+          <a:bodyPr rtlCol="0" anchor="ctr"/>
+          <a:lstStyle/>
+          <a:p>
+            <a:pPr algn="ctr"/>
+          </a:p>
+        </p:txBody>
+      </p:sp>
+      <p:pic>
+        <p:nvPicPr>
+          <p:cNvPr id="3" name="Picture 2" descr="logo.png"/>
+          <p:cNvPicPr>
+            <a:picLocks noChangeAspect="1"/>
+          </p:cNvPicPr>
+          <p:nvPr/>
+        </p:nvPicPr>
+        <p:blipFill>
+          <a:blip r:embed="rId2"/>
+          <a:stretch>
+            <a:fillRect/>
+          </a:stretch>
+        </p:blipFill>
+        <p:spPr>
+          <a:xfrm>
+            <a:off x="4926722" y="1828800"/>
+            <a:ext cx="2338251" cy="1463040"/>
+          </a:xfrm>
+          <a:prstGeom prst="rect">
+            <a:avLst/>
+          </a:prstGeom>
+        </p:spPr>
+      </p:pic>
+      <p:sp>
+        <p:nvSpPr>
+          <p:cNvPr id="4" name="TextBox 3"/>
+          <p:cNvSpPr txBox="1"/>
+          <p:nvPr/>
+        </p:nvSpPr>
+        <p:spPr>
+          <a:xfrm>
+            <a:off x="914400" y="3566160"/>
+            <a:ext cx="10360152" cy="914400"/>
+          </a:xfrm>
+          <a:prstGeom prst="rect">
+            <a:avLst/>
+          </a:prstGeom>
+          <a:noFill/>
+        </p:spPr>
+        <p:txBody>
+          <a:bodyPr wrap="square">
+            <a:spAutoFit/>
+          </a:bodyPr>
+          <a:lstStyle/>
+          <a:p>
+            <a:pPr algn="ctr"/>
+            <a:r>
+              <a:rPr sz="3600" b="1" i="0">
+                <a:solidFill>
+                  <a:srgbClr val="FFFFFF"/>
+                </a:solidFill>
+                <a:latin typeface="Calibri"/>
+              </a:rPr>
+              <a:t>Merci de votre attention</a:t>
+            </a:r>
+          </a:p>
+        </p:txBody>
+      </p:sp>
+      <p:sp>
+        <p:nvSpPr>
+          <p:cNvPr id="5" name="TextBox 4"/>
+          <p:cNvSpPr txBox="1"/>
+          <p:nvPr/>
+        </p:nvSpPr>
+        <p:spPr>
+          <a:xfrm>
+            <a:off x="914400" y="4480560"/>
+            <a:ext cx="10360152" cy="548640"/>
+          </a:xfrm>
+          <a:prstGeom prst="rect">
+            <a:avLst/>
+          </a:prstGeom>
+          <a:noFill/>
+        </p:spPr>
+        <p:txBody>
+          <a:bodyPr wrap="square">
+            <a:spAutoFit/>
+          </a:bodyPr>
+          <a:lstStyle/>
+          <a:p>
+            <a:pPr algn="ctr"/>
+            <a:r>
+              <a:rPr sz="2000" b="0" i="0">
+                <a:solidFill>
+                  <a:srgbClr val="BFD7F2"/>
+                </a:solidFill>
+                <a:latin typeface="Calibri"/>
+              </a:rPr>
+              <a:t>Questions &amp; discussion</a:t>
+            </a:r>
+          </a:p>
+        </p:txBody>
+      </p:sp>
+    </p:spTree>
+  </p:cSld>
+  <p:clrMapOvr>
+    <a:masterClrMapping/>
+  </p:clrMapOvr>
+</p:sld>
+</file>
+
 <file path=ppt/slides/slide3.xml><?xml version="1.0" encoding="utf-8"?>
 <p:sld xmlns:a="http://schemas.openxmlformats.org/drawingml/2006/main" xmlns:p="http://schemas.openxmlformats.org/presentationml/2006/main" xmlns:r="http://schemas.openxmlformats.org/officeDocument/2006/relationships">
   <p:cSld>
@@ -8157,6 +10768,11 @@
           <a:prstGeom prst="rect">
             <a:avLst/>
           </a:prstGeom>
+          <a:ln w="9525">
+            <a:solidFill>
+              <a:srgbClr val="E0E0E6"/>
+            </a:solidFill>
+          </a:ln>
         </p:spPr>
       </p:pic>
       <p:sp>
@@ -8167,7 +10783,7 @@
         </p:nvSpPr>
         <p:spPr>
           <a:xfrm>
-            <a:off x="640080" y="6263640"/>
+            <a:off x="640080" y="6355080"/>
             <a:ext cx="10881360" cy="365760"/>
           </a:xfrm>
           <a:prstGeom prst="rect">
@@ -8398,6 +11014,11 @@
           <a:prstGeom prst="rect">
             <a:avLst/>
           </a:prstGeom>
+          <a:ln w="9525">
+            <a:solidFill>
+              <a:srgbClr val="E0E0E6"/>
+            </a:solidFill>
+          </a:ln>
         </p:spPr>
       </p:pic>
       <p:sp>
@@ -8408,7 +11029,7 @@
         </p:nvSpPr>
         <p:spPr>
           <a:xfrm>
-            <a:off x="640080" y="6263640"/>
+            <a:off x="640080" y="6355080"/>
             <a:ext cx="10881360" cy="365760"/>
           </a:xfrm>
           <a:prstGeom prst="rect">
@@ -8639,6 +11260,11 @@
           <a:prstGeom prst="rect">
             <a:avLst/>
           </a:prstGeom>
+          <a:ln w="9525">
+            <a:solidFill>
+              <a:srgbClr val="E0E0E6"/>
+            </a:solidFill>
+          </a:ln>
         </p:spPr>
       </p:pic>
       <p:sp>
@@ -8649,7 +11275,7 @@
         </p:nvSpPr>
         <p:spPr>
           <a:xfrm>
-            <a:off x="640080" y="6263640"/>
+            <a:off x="640080" y="6355080"/>
             <a:ext cx="10881360" cy="365760"/>
           </a:xfrm>
           <a:prstGeom prst="rect">
@@ -8880,6 +11506,11 @@
           <a:prstGeom prst="rect">
             <a:avLst/>
           </a:prstGeom>
+          <a:ln w="9525">
+            <a:solidFill>
+              <a:srgbClr val="E0E0E6"/>
+            </a:solidFill>
+          </a:ln>
         </p:spPr>
       </p:pic>
       <p:sp>
@@ -8890,7 +11521,7 @@
         </p:nvSpPr>
         <p:spPr>
           <a:xfrm>
-            <a:off x="640080" y="6263640"/>
+            <a:off x="640080" y="6355080"/>
             <a:ext cx="10881360" cy="365760"/>
           </a:xfrm>
           <a:prstGeom prst="rect">

</xml_diff>

<commit_message>
Présentation PFE : équilibrage de la diapositive « Place de marché »
Cadre du diagramme de séquence ajusté (panneau adapté à l'image et centré)
après vérification visuelle de l'ensemble des diapositives.
</commit_message>
<xml_diff>
--- a/docs/TousLocation-Soutenance.pptx
+++ b/docs/TousLocation-Soutenance.pptx
@@ -7864,8 +7864,8 @@
         </p:nvSpPr>
         <p:spPr>
           <a:xfrm>
-            <a:off x="6537960" y="1828800"/>
-            <a:ext cx="5349240" cy="4297680"/>
+            <a:off x="6492240" y="2444526"/>
+            <a:ext cx="5431536" cy="2609025"/>
           </a:xfrm>
           <a:prstGeom prst="roundRect">
             <a:avLst>
@@ -7920,12 +7920,17 @@
         </p:blipFill>
         <p:spPr>
           <a:xfrm>
-            <a:off x="6606540" y="2057400"/>
-            <a:ext cx="5212080" cy="2286933"/>
-          </a:xfrm>
-          <a:prstGeom prst="rect">
-            <a:avLst/>
-          </a:prstGeom>
+            <a:off x="6693408" y="2645694"/>
+            <a:ext cx="5029200" cy="2206689"/>
+          </a:xfrm>
+          <a:prstGeom prst="rect">
+            <a:avLst/>
+          </a:prstGeom>
+          <a:ln w="9525">
+            <a:solidFill>
+              <a:srgbClr val="E2E8F0"/>
+            </a:solidFill>
+          </a:ln>
         </p:spPr>
       </p:pic>
     </p:spTree>

</xml_diff>